<commit_message>
docs/presentation: split deck across 5 presenters
- Add per-slide speaker notes assigning each slide to a presenter (5 thematic
  blocks: Intro / Data Engineering / Models+Reproduction / Phase-2 Tiers /
  Efficiency+Conclusion) with delivery + hand-off cues.
- Add the 5-presenter split table to the panel prep guide.

Co-Authored-By: Claude Opus 4.8 (1M context) <noreply@anthropic.com>
</commit_message>
<xml_diff>
--- a/docs/presentation/Capstone_Final_Presentation.pptx
+++ b/docs/presentation/Capstone_Final_Presentation.pptx
@@ -121,6 +121,1631 @@
     </a:lvl9pPr>
   </p:defaultTextStyle>
 </p:presentation>
+</file>
+
+<file path=ppt/notesMasters/notesMaster1.xml><?xml version="1.0" encoding="utf-8"?>
+<p:notesMaster xmlns:a="http://schemas.openxmlformats.org/drawingml/2006/main" xmlns:p="http://schemas.openxmlformats.org/presentationml/2006/main" xmlns:r="http://schemas.openxmlformats.org/officeDocument/2006/relationships">
+  <p:cSld>
+    <p:bg>
+      <p:bgRef idx="1001">
+        <a:schemeClr val="bg1"/>
+      </p:bgRef>
+    </p:bg>
+    <p:spTree>
+      <p:nvGrpSpPr>
+        <p:cNvPr id="1" name=""/>
+        <p:cNvGrpSpPr/>
+        <p:nvPr/>
+      </p:nvGrpSpPr>
+      <p:grpSpPr>
+        <a:xfrm>
+          <a:off x="0" y="0"/>
+          <a:ext cx="0" cy="0"/>
+          <a:chOff x="0" y="0"/>
+          <a:chExt cx="0" cy="0"/>
+        </a:xfrm>
+      </p:grpSpPr>
+      <p:sp>
+        <p:nvSpPr>
+          <p:cNvPr id="2" name="Header Placeholder 1"/>
+          <p:cNvSpPr>
+            <a:spLocks noGrp="1"/>
+          </p:cNvSpPr>
+          <p:nvPr>
+            <p:ph type="hdr" sz="quarter"/>
+          </p:nvPr>
+        </p:nvSpPr>
+        <p:spPr>
+          <a:xfrm>
+            <a:off x="0" y="0"/>
+            <a:ext cx="2971800" cy="457200"/>
+          </a:xfrm>
+          <a:prstGeom prst="rect">
+            <a:avLst/>
+          </a:prstGeom>
+        </p:spPr>
+        <p:txBody>
+          <a:bodyPr vert="horz" lIns="91440" tIns="45720" rIns="91440" bIns="45720" rtlCol="0"/>
+          <a:lstStyle>
+            <a:lvl1pPr algn="l">
+              <a:defRPr sz="1200"/>
+            </a:lvl1pPr>
+          </a:lstStyle>
+          <a:p>
+            <a:endParaRPr lang="en-US"/>
+          </a:p>
+        </p:txBody>
+      </p:sp>
+      <p:sp>
+        <p:nvSpPr>
+          <p:cNvPr id="3" name="Date Placeholder 2"/>
+          <p:cNvSpPr>
+            <a:spLocks noGrp="1"/>
+          </p:cNvSpPr>
+          <p:nvPr>
+            <p:ph type="dt" idx="1"/>
+          </p:nvPr>
+        </p:nvSpPr>
+        <p:spPr>
+          <a:xfrm>
+            <a:off x="3884613" y="0"/>
+            <a:ext cx="2971800" cy="457200"/>
+          </a:xfrm>
+          <a:prstGeom prst="rect">
+            <a:avLst/>
+          </a:prstGeom>
+        </p:spPr>
+        <p:txBody>
+          <a:bodyPr vert="horz" lIns="91440" tIns="45720" rIns="91440" bIns="45720" rtlCol="0"/>
+          <a:lstStyle>
+            <a:lvl1pPr algn="r">
+              <a:defRPr sz="1200"/>
+            </a:lvl1pPr>
+          </a:lstStyle>
+          <a:p>
+            <a:fld id="{0F89C1C7-3DCD-1040-A9CF-14679D8B5DDD}" type="datetimeFigureOut">
+              <a:rPr lang="en-US" smtClean="0"/>
+              <a:t>10/17/16</a:t>
+            </a:fld>
+            <a:endParaRPr lang="en-US"/>
+          </a:p>
+        </p:txBody>
+      </p:sp>
+      <p:sp>
+        <p:nvSpPr>
+          <p:cNvPr id="4" name="Slide Image Placeholder 3"/>
+          <p:cNvSpPr>
+            <a:spLocks noGrp="1" noRot="1" noChangeAspect="1"/>
+          </p:cNvSpPr>
+          <p:nvPr>
+            <p:ph type="sldImg" idx="2"/>
+          </p:nvPr>
+        </p:nvSpPr>
+        <p:spPr>
+          <a:xfrm>
+            <a:off x="1143000" y="685800"/>
+            <a:ext cx="4572000" cy="3429000"/>
+          </a:xfrm>
+          <a:prstGeom prst="rect">
+            <a:avLst/>
+          </a:prstGeom>
+          <a:noFill/>
+          <a:ln w="12700">
+            <a:solidFill>
+              <a:prstClr val="black"/>
+            </a:solidFill>
+          </a:ln>
+        </p:spPr>
+        <p:txBody>
+          <a:bodyPr vert="horz" lIns="91440" tIns="45720" rIns="91440" bIns="45720" rtlCol="0" anchor="ctr"/>
+          <a:lstStyle/>
+          <a:p>
+            <a:endParaRPr lang="en-US"/>
+          </a:p>
+        </p:txBody>
+      </p:sp>
+      <p:sp>
+        <p:nvSpPr>
+          <p:cNvPr id="5" name="Notes Placeholder 4"/>
+          <p:cNvSpPr>
+            <a:spLocks noGrp="1"/>
+          </p:cNvSpPr>
+          <p:nvPr>
+            <p:ph type="body" sz="quarter" idx="3"/>
+          </p:nvPr>
+        </p:nvSpPr>
+        <p:spPr>
+          <a:xfrm>
+            <a:off x="685800" y="4343400"/>
+            <a:ext cx="5486400" cy="4114800"/>
+          </a:xfrm>
+          <a:prstGeom prst="rect">
+            <a:avLst/>
+          </a:prstGeom>
+        </p:spPr>
+        <p:txBody>
+          <a:bodyPr vert="horz" lIns="91440" tIns="45720" rIns="91440" bIns="45720" rtlCol="0"/>
+          <a:lstStyle/>
+          <a:p>
+            <a:pPr lvl="0"/>
+            <a:r>
+              <a:rPr lang="en-US" smtClean="0"/>
+              <a:t>Click to edit Master text styles</a:t>
+            </a:r>
+          </a:p>
+          <a:p>
+            <a:pPr lvl="1"/>
+            <a:r>
+              <a:rPr lang="en-US" smtClean="0"/>
+              <a:t>Second level</a:t>
+            </a:r>
+          </a:p>
+          <a:p>
+            <a:pPr lvl="2"/>
+            <a:r>
+              <a:rPr lang="en-US" smtClean="0"/>
+              <a:t>Third level</a:t>
+            </a:r>
+          </a:p>
+          <a:p>
+            <a:pPr lvl="3"/>
+            <a:r>
+              <a:rPr lang="en-US" smtClean="0"/>
+              <a:t>Fourth level</a:t>
+            </a:r>
+          </a:p>
+          <a:p>
+            <a:pPr lvl="4"/>
+            <a:r>
+              <a:rPr lang="en-US" smtClean="0"/>
+              <a:t>Fifth level</a:t>
+            </a:r>
+            <a:endParaRPr lang="en-US"/>
+          </a:p>
+        </p:txBody>
+      </p:sp>
+      <p:sp>
+        <p:nvSpPr>
+          <p:cNvPr id="6" name="Footer Placeholder 5"/>
+          <p:cNvSpPr>
+            <a:spLocks noGrp="1"/>
+          </p:cNvSpPr>
+          <p:nvPr>
+            <p:ph type="ftr" sz="quarter" idx="4"/>
+          </p:nvPr>
+        </p:nvSpPr>
+        <p:spPr>
+          <a:xfrm>
+            <a:off x="0" y="8685213"/>
+            <a:ext cx="2971800" cy="457200"/>
+          </a:xfrm>
+          <a:prstGeom prst="rect">
+            <a:avLst/>
+          </a:prstGeom>
+        </p:spPr>
+        <p:txBody>
+          <a:bodyPr vert="horz" lIns="91440" tIns="45720" rIns="91440" bIns="45720" rtlCol="0" anchor="b"/>
+          <a:lstStyle>
+            <a:lvl1pPr algn="l">
+              <a:defRPr sz="1200"/>
+            </a:lvl1pPr>
+          </a:lstStyle>
+          <a:p>
+            <a:endParaRPr lang="en-US"/>
+          </a:p>
+        </p:txBody>
+      </p:sp>
+      <p:sp>
+        <p:nvSpPr>
+          <p:cNvPr id="7" name="Slide Number Placeholder 6"/>
+          <p:cNvSpPr>
+            <a:spLocks noGrp="1"/>
+          </p:cNvSpPr>
+          <p:nvPr>
+            <p:ph type="sldNum" sz="quarter" idx="5"/>
+          </p:nvPr>
+        </p:nvSpPr>
+        <p:spPr>
+          <a:xfrm>
+            <a:off x="3884613" y="8685213"/>
+            <a:ext cx="2971800" cy="457200"/>
+          </a:xfrm>
+          <a:prstGeom prst="rect">
+            <a:avLst/>
+          </a:prstGeom>
+        </p:spPr>
+        <p:txBody>
+          <a:bodyPr vert="horz" lIns="91440" tIns="45720" rIns="91440" bIns="45720" rtlCol="0" anchor="b"/>
+          <a:lstStyle>
+            <a:lvl1pPr algn="r">
+              <a:defRPr sz="1200"/>
+            </a:lvl1pPr>
+          </a:lstStyle>
+          <a:p>
+            <a:fld id="{BB5E49A5-4136-284D-997B-48E1D791AD67}" type="slidenum">
+              <a:rPr lang="en-US" smtClean="0"/>
+              <a:t>‹#›</a:t>
+            </a:fld>
+            <a:endParaRPr lang="en-US"/>
+          </a:p>
+        </p:txBody>
+      </p:sp>
+    </p:spTree>
+    <p:extLst>
+      <p:ext uri="{BB962C8B-B14F-4D97-AF65-F5344CB8AC3E}">
+        <p14:creationId xmlns:p14="http://schemas.microsoft.com/office/powerpoint/2010/main" val="2623252185"/>
+      </p:ext>
+    </p:extLst>
+  </p:cSld>
+  <p:clrMap bg1="lt1" tx1="dk1" bg2="lt2" tx2="dk2" accent1="accent1" accent2="accent2" accent3="accent3" accent4="accent4" accent5="accent5" accent6="accent6" hlink="hlink" folHlink="folHlink"/>
+  <p:notesStyle>
+    <a:lvl1pPr marL="0" algn="l" defTabSz="457200" rtl="0" eaLnBrk="1" latinLnBrk="0" hangingPunct="1">
+      <a:defRPr sz="1200" kern="1200">
+        <a:solidFill>
+          <a:schemeClr val="tx1"/>
+        </a:solidFill>
+        <a:latin typeface="+mn-lt"/>
+        <a:ea typeface="+mn-ea"/>
+        <a:cs typeface="+mn-cs"/>
+      </a:defRPr>
+    </a:lvl1pPr>
+    <a:lvl2pPr marL="457200" algn="l" defTabSz="457200" rtl="0" eaLnBrk="1" latinLnBrk="0" hangingPunct="1">
+      <a:defRPr sz="1200" kern="1200">
+        <a:solidFill>
+          <a:schemeClr val="tx1"/>
+        </a:solidFill>
+        <a:latin typeface="+mn-lt"/>
+        <a:ea typeface="+mn-ea"/>
+        <a:cs typeface="+mn-cs"/>
+      </a:defRPr>
+    </a:lvl2pPr>
+    <a:lvl3pPr marL="914400" algn="l" defTabSz="457200" rtl="0" eaLnBrk="1" latinLnBrk="0" hangingPunct="1">
+      <a:defRPr sz="1200" kern="1200">
+        <a:solidFill>
+          <a:schemeClr val="tx1"/>
+        </a:solidFill>
+        <a:latin typeface="+mn-lt"/>
+        <a:ea typeface="+mn-ea"/>
+        <a:cs typeface="+mn-cs"/>
+      </a:defRPr>
+    </a:lvl3pPr>
+    <a:lvl4pPr marL="1371600" algn="l" defTabSz="457200" rtl="0" eaLnBrk="1" latinLnBrk="0" hangingPunct="1">
+      <a:defRPr sz="1200" kern="1200">
+        <a:solidFill>
+          <a:schemeClr val="tx1"/>
+        </a:solidFill>
+        <a:latin typeface="+mn-lt"/>
+        <a:ea typeface="+mn-ea"/>
+        <a:cs typeface="+mn-cs"/>
+      </a:defRPr>
+    </a:lvl4pPr>
+    <a:lvl5pPr marL="1828800" algn="l" defTabSz="457200" rtl="0" eaLnBrk="1" latinLnBrk="0" hangingPunct="1">
+      <a:defRPr sz="1200" kern="1200">
+        <a:solidFill>
+          <a:schemeClr val="tx1"/>
+        </a:solidFill>
+        <a:latin typeface="+mn-lt"/>
+        <a:ea typeface="+mn-ea"/>
+        <a:cs typeface="+mn-cs"/>
+      </a:defRPr>
+    </a:lvl5pPr>
+    <a:lvl6pPr marL="2286000" algn="l" defTabSz="457200" rtl="0" eaLnBrk="1" latinLnBrk="0" hangingPunct="1">
+      <a:defRPr sz="1200" kern="1200">
+        <a:solidFill>
+          <a:schemeClr val="tx1"/>
+        </a:solidFill>
+        <a:latin typeface="+mn-lt"/>
+        <a:ea typeface="+mn-ea"/>
+        <a:cs typeface="+mn-cs"/>
+      </a:defRPr>
+    </a:lvl6pPr>
+    <a:lvl7pPr marL="2743200" algn="l" defTabSz="457200" rtl="0" eaLnBrk="1" latinLnBrk="0" hangingPunct="1">
+      <a:defRPr sz="1200" kern="1200">
+        <a:solidFill>
+          <a:schemeClr val="tx1"/>
+        </a:solidFill>
+        <a:latin typeface="+mn-lt"/>
+        <a:ea typeface="+mn-ea"/>
+        <a:cs typeface="+mn-cs"/>
+      </a:defRPr>
+    </a:lvl7pPr>
+    <a:lvl8pPr marL="3200400" algn="l" defTabSz="457200" rtl="0" eaLnBrk="1" latinLnBrk="0" hangingPunct="1">
+      <a:defRPr sz="1200" kern="1200">
+        <a:solidFill>
+          <a:schemeClr val="tx1"/>
+        </a:solidFill>
+        <a:latin typeface="+mn-lt"/>
+        <a:ea typeface="+mn-ea"/>
+        <a:cs typeface="+mn-cs"/>
+      </a:defRPr>
+    </a:lvl8pPr>
+    <a:lvl9pPr marL="3657600" algn="l" defTabSz="457200" rtl="0" eaLnBrk="1" latinLnBrk="0" hangingPunct="1">
+      <a:defRPr sz="1200" kern="1200">
+        <a:solidFill>
+          <a:schemeClr val="tx1"/>
+        </a:solidFill>
+        <a:latin typeface="+mn-lt"/>
+        <a:ea typeface="+mn-ea"/>
+        <a:cs typeface="+mn-cs"/>
+      </a:defRPr>
+    </a:lvl9pPr>
+  </p:notesStyle>
+</p:notesMaster>
+</file>
+
+<file path=ppt/notesSlides/notesSlide1.xml><?xml version="1.0" encoding="utf-8"?>
+<p:notes xmlns:a="http://schemas.openxmlformats.org/drawingml/2006/main" xmlns:p="http://schemas.openxmlformats.org/presentationml/2006/main" xmlns:r="http://schemas.openxmlformats.org/officeDocument/2006/relationships">
+  <p:cSld>
+    <p:spTree>
+      <p:nvGrpSpPr>
+        <p:cNvPr id="1" name=""/>
+        <p:cNvGrpSpPr/>
+        <p:nvPr/>
+      </p:nvGrpSpPr>
+      <p:grpSpPr>
+        <a:xfrm>
+          <a:off x="0" y="0"/>
+          <a:ext cx="0" cy="0"/>
+          <a:chOff x="0" y="0"/>
+          <a:chExt cx="0" cy="0"/>
+        </a:xfrm>
+      </p:grpSpPr>
+      <p:sp>
+        <p:nvSpPr>
+          <p:cNvPr id="2" name="Slide Image Placeholder 1"/>
+          <p:cNvSpPr>
+            <a:spLocks noGrp="1"/>
+          </p:cNvSpPr>
+          <p:nvPr>
+            <p:ph type="sldImg" idx="2"/>
+          </p:nvPr>
+        </p:nvSpPr>
+        <p:spPr/>
+      </p:sp>
+      <p:sp>
+        <p:nvSpPr>
+          <p:cNvPr id="3" name="Notes Placeholder 2"/>
+          <p:cNvSpPr>
+            <a:spLocks noGrp="1"/>
+          </p:cNvSpPr>
+          <p:nvPr>
+            <p:ph type="body" idx="3" sz="quarter"/>
+          </p:nvPr>
+        </p:nvSpPr>
+        <p:spPr/>
+        <p:txBody>
+          <a:bodyPr/>
+          <a:lstStyle/>
+          <a:p>
+            <a:r>
+              <a:t>PRESENTER 1 — Sumanth G M (Intro &amp; Motivation).</a:t>
+            </a:r>
+          </a:p>
+          <a:p>
+            <a:r>
+              <a:t>Welcome the panel; state the title and the one-line problem: predict short-horizon mid-price direction from LOB data. Hand off after Related Work to Joseph.</a:t>
+            </a:r>
+          </a:p>
+        </p:txBody>
+      </p:sp>
+      <p:sp>
+        <p:nvSpPr>
+          <p:cNvPr id="4" name="Slide Number Placeholder 3"/>
+          <p:cNvSpPr>
+            <a:spLocks noGrp="1"/>
+          </p:cNvSpPr>
+          <p:nvPr>
+            <p:ph type="sldNum" idx="5" sz="quarter"/>
+          </p:nvPr>
+        </p:nvSpPr>
+        <p:spPr/>
+      </p:sp>
+    </p:spTree>
+  </p:cSld>
+  <p:clrMapOvr>
+    <a:masterClrMapping/>
+  </p:clrMapOvr>
+</p:notes>
+</file>
+
+<file path=ppt/notesSlides/notesSlide10.xml><?xml version="1.0" encoding="utf-8"?>
+<p:notes xmlns:a="http://schemas.openxmlformats.org/drawingml/2006/main" xmlns:p="http://schemas.openxmlformats.org/presentationml/2006/main" xmlns:r="http://schemas.openxmlformats.org/officeDocument/2006/relationships">
+  <p:cSld>
+    <p:spTree>
+      <p:nvGrpSpPr>
+        <p:cNvPr id="1" name=""/>
+        <p:cNvGrpSpPr/>
+        <p:nvPr/>
+      </p:nvGrpSpPr>
+      <p:grpSpPr>
+        <a:xfrm>
+          <a:off x="0" y="0"/>
+          <a:ext cx="0" cy="0"/>
+          <a:chOff x="0" y="0"/>
+          <a:chExt cx="0" cy="0"/>
+        </a:xfrm>
+      </p:grpSpPr>
+      <p:sp>
+        <p:nvSpPr>
+          <p:cNvPr id="2" name="Slide Image Placeholder 1"/>
+          <p:cNvSpPr>
+            <a:spLocks noGrp="1"/>
+          </p:cNvSpPr>
+          <p:nvPr>
+            <p:ph type="sldImg" idx="2"/>
+          </p:nvPr>
+        </p:nvSpPr>
+        <p:spPr/>
+      </p:sp>
+      <p:sp>
+        <p:nvSpPr>
+          <p:cNvPr id="3" name="Notes Placeholder 2"/>
+          <p:cNvSpPr>
+            <a:spLocks noGrp="1"/>
+          </p:cNvSpPr>
+          <p:nvPr>
+            <p:ph type="body" idx="3" sz="quarter"/>
+          </p:nvPr>
+        </p:nvSpPr>
+        <p:spPr/>
+        <p:txBody>
+          <a:bodyPr/>
+          <a:lstStyle/>
+          <a:p>
+            <a:r>
+              <a:t>PRESENTER 3 — Abhishek Kumar.</a:t>
+            </a:r>
+          </a:p>
+          <a:p>
+            <a:r>
+              <a:t>FI-2010 reproduction validates the pipeline: DeepLOB ~= paper, TLOB in SOTA range.</a:t>
+            </a:r>
+          </a:p>
+        </p:txBody>
+      </p:sp>
+      <p:sp>
+        <p:nvSpPr>
+          <p:cNvPr id="4" name="Slide Number Placeholder 3"/>
+          <p:cNvSpPr>
+            <a:spLocks noGrp="1"/>
+          </p:cNvSpPr>
+          <p:nvPr>
+            <p:ph type="sldNum" idx="5" sz="quarter"/>
+          </p:nvPr>
+        </p:nvSpPr>
+        <p:spPr/>
+      </p:sp>
+    </p:spTree>
+  </p:cSld>
+  <p:clrMapOvr>
+    <a:masterClrMapping/>
+  </p:clrMapOvr>
+</p:notes>
+</file>
+
+<file path=ppt/notesSlides/notesSlide11.xml><?xml version="1.0" encoding="utf-8"?>
+<p:notes xmlns:a="http://schemas.openxmlformats.org/drawingml/2006/main" xmlns:p="http://schemas.openxmlformats.org/presentationml/2006/main" xmlns:r="http://schemas.openxmlformats.org/officeDocument/2006/relationships">
+  <p:cSld>
+    <p:spTree>
+      <p:nvGrpSpPr>
+        <p:cNvPr id="1" name=""/>
+        <p:cNvGrpSpPr/>
+        <p:nvPr/>
+      </p:nvGrpSpPr>
+      <p:grpSpPr>
+        <a:xfrm>
+          <a:off x="0" y="0"/>
+          <a:ext cx="0" cy="0"/>
+          <a:chOff x="0" y="0"/>
+          <a:chExt cx="0" cy="0"/>
+        </a:xfrm>
+      </p:grpSpPr>
+      <p:sp>
+        <p:nvSpPr>
+          <p:cNvPr id="2" name="Slide Image Placeholder 1"/>
+          <p:cNvSpPr>
+            <a:spLocks noGrp="1"/>
+          </p:cNvSpPr>
+          <p:nvPr>
+            <p:ph type="sldImg" idx="2"/>
+          </p:nvPr>
+        </p:nvSpPr>
+        <p:spPr/>
+      </p:sp>
+      <p:sp>
+        <p:nvSpPr>
+          <p:cNvPr id="3" name="Notes Placeholder 2"/>
+          <p:cNvSpPr>
+            <a:spLocks noGrp="1"/>
+          </p:cNvSpPr>
+          <p:nvPr>
+            <p:ph type="body" idx="3" sz="quarter"/>
+          </p:nvPr>
+        </p:nvSpPr>
+        <p:spPr/>
+        <p:txBody>
+          <a:bodyPr/>
+          <a:lstStyle/>
+          <a:p>
+            <a:r>
+              <a:t>PRESENTER 3 — Abhishek Kumar.</a:t>
+            </a:r>
+          </a:p>
+          <a:p>
+            <a:r>
+              <a:t>NSE transfer: all beat baselines (signal exists); below FI-2010 (expected); TLOB leads; MambaLOB beats DeepLOB on NIFTY at 1/27 params. Hand to Raghav for Phase-2.</a:t>
+            </a:r>
+          </a:p>
+        </p:txBody>
+      </p:sp>
+      <p:sp>
+        <p:nvSpPr>
+          <p:cNvPr id="4" name="Slide Number Placeholder 3"/>
+          <p:cNvSpPr>
+            <a:spLocks noGrp="1"/>
+          </p:cNvSpPr>
+          <p:nvPr>
+            <p:ph type="sldNum" idx="5" sz="quarter"/>
+          </p:nvPr>
+        </p:nvSpPr>
+        <p:spPr/>
+      </p:sp>
+    </p:spTree>
+  </p:cSld>
+  <p:clrMapOvr>
+    <a:masterClrMapping/>
+  </p:clrMapOvr>
+</p:notes>
+</file>
+
+<file path=ppt/notesSlides/notesSlide12.xml><?xml version="1.0" encoding="utf-8"?>
+<p:notes xmlns:a="http://schemas.openxmlformats.org/drawingml/2006/main" xmlns:p="http://schemas.openxmlformats.org/presentationml/2006/main" xmlns:r="http://schemas.openxmlformats.org/officeDocument/2006/relationships">
+  <p:cSld>
+    <p:spTree>
+      <p:nvGrpSpPr>
+        <p:cNvPr id="1" name=""/>
+        <p:cNvGrpSpPr/>
+        <p:nvPr/>
+      </p:nvGrpSpPr>
+      <p:grpSpPr>
+        <a:xfrm>
+          <a:off x="0" y="0"/>
+          <a:ext cx="0" cy="0"/>
+          <a:chOff x="0" y="0"/>
+          <a:chExt cx="0" cy="0"/>
+        </a:xfrm>
+      </p:grpSpPr>
+      <p:sp>
+        <p:nvSpPr>
+          <p:cNvPr id="2" name="Slide Image Placeholder 1"/>
+          <p:cNvSpPr>
+            <a:spLocks noGrp="1"/>
+          </p:cNvSpPr>
+          <p:nvPr>
+            <p:ph type="sldImg" idx="2"/>
+          </p:nvPr>
+        </p:nvSpPr>
+        <p:spPr/>
+      </p:sp>
+      <p:sp>
+        <p:nvSpPr>
+          <p:cNvPr id="3" name="Notes Placeholder 2"/>
+          <p:cNvSpPr>
+            <a:spLocks noGrp="1"/>
+          </p:cNvSpPr>
+          <p:nvPr>
+            <p:ph type="body" idx="3" sz="quarter"/>
+          </p:nvPr>
+        </p:nvSpPr>
+        <p:spPr/>
+        <p:txBody>
+          <a:bodyPr/>
+          <a:lstStyle/>
+          <a:p>
+            <a:r>
+              <a:t>PRESENTER 4 — R Raghav Srivatsav (Phase-2 DS contributions).</a:t>
+            </a:r>
+          </a:p>
+          <a:p>
+            <a:r>
+              <a:t>Tier A: microstructure features give a SIGNIFICANT gain (+0.084 wF1, p=0.001).</a:t>
+            </a:r>
+          </a:p>
+        </p:txBody>
+      </p:sp>
+      <p:sp>
+        <p:nvSpPr>
+          <p:cNvPr id="4" name="Slide Number Placeholder 3"/>
+          <p:cNvSpPr>
+            <a:spLocks noGrp="1"/>
+          </p:cNvSpPr>
+          <p:nvPr>
+            <p:ph type="sldNum" idx="5" sz="quarter"/>
+          </p:nvPr>
+        </p:nvSpPr>
+        <p:spPr/>
+      </p:sp>
+    </p:spTree>
+  </p:cSld>
+  <p:clrMapOvr>
+    <a:masterClrMapping/>
+  </p:clrMapOvr>
+</p:notes>
+</file>
+
+<file path=ppt/notesSlides/notesSlide13.xml><?xml version="1.0" encoding="utf-8"?>
+<p:notes xmlns:a="http://schemas.openxmlformats.org/drawingml/2006/main" xmlns:p="http://schemas.openxmlformats.org/presentationml/2006/main" xmlns:r="http://schemas.openxmlformats.org/officeDocument/2006/relationships">
+  <p:cSld>
+    <p:spTree>
+      <p:nvGrpSpPr>
+        <p:cNvPr id="1" name=""/>
+        <p:cNvGrpSpPr/>
+        <p:nvPr/>
+      </p:nvGrpSpPr>
+      <p:grpSpPr>
+        <a:xfrm>
+          <a:off x="0" y="0"/>
+          <a:ext cx="0" cy="0"/>
+          <a:chOff x="0" y="0"/>
+          <a:chExt cx="0" cy="0"/>
+        </a:xfrm>
+      </p:grpSpPr>
+      <p:sp>
+        <p:nvSpPr>
+          <p:cNvPr id="2" name="Slide Image Placeholder 1"/>
+          <p:cNvSpPr>
+            <a:spLocks noGrp="1"/>
+          </p:cNvSpPr>
+          <p:nvPr>
+            <p:ph type="sldImg" idx="2"/>
+          </p:nvPr>
+        </p:nvSpPr>
+        <p:spPr/>
+      </p:sp>
+      <p:sp>
+        <p:nvSpPr>
+          <p:cNvPr id="3" name="Notes Placeholder 2"/>
+          <p:cNvSpPr>
+            <a:spLocks noGrp="1"/>
+          </p:cNvSpPr>
+          <p:nvPr>
+            <p:ph type="body" idx="3" sz="quarter"/>
+          </p:nvPr>
+        </p:nvSpPr>
+        <p:spPr/>
+        <p:txBody>
+          <a:bodyPr/>
+          <a:lstStyle/>
+          <a:p>
+            <a:r>
+              <a:t>PRESENTER 4 — R Raghav Srivatsav.</a:t>
+            </a:r>
+          </a:p>
+          <a:p>
+            <a:r>
+              <a:t>Tier B: ConvMambaLOB best of ours, ~90% of TLOB at 12.5x fewer params. Honest: efficiency trade-off, not accuracy win.</a:t>
+            </a:r>
+          </a:p>
+        </p:txBody>
+      </p:sp>
+      <p:sp>
+        <p:nvSpPr>
+          <p:cNvPr id="4" name="Slide Number Placeholder 3"/>
+          <p:cNvSpPr>
+            <a:spLocks noGrp="1"/>
+          </p:cNvSpPr>
+          <p:nvPr>
+            <p:ph type="sldNum" idx="5" sz="quarter"/>
+          </p:nvPr>
+        </p:nvSpPr>
+        <p:spPr/>
+      </p:sp>
+    </p:spTree>
+  </p:cSld>
+  <p:clrMapOvr>
+    <a:masterClrMapping/>
+  </p:clrMapOvr>
+</p:notes>
+</file>
+
+<file path=ppt/notesSlides/notesSlide14.xml><?xml version="1.0" encoding="utf-8"?>
+<p:notes xmlns:a="http://schemas.openxmlformats.org/drawingml/2006/main" xmlns:p="http://schemas.openxmlformats.org/presentationml/2006/main" xmlns:r="http://schemas.openxmlformats.org/officeDocument/2006/relationships">
+  <p:cSld>
+    <p:spTree>
+      <p:nvGrpSpPr>
+        <p:cNvPr id="1" name=""/>
+        <p:cNvGrpSpPr/>
+        <p:nvPr/>
+      </p:nvGrpSpPr>
+      <p:grpSpPr>
+        <a:xfrm>
+          <a:off x="0" y="0"/>
+          <a:ext cx="0" cy="0"/>
+          <a:chOff x="0" y="0"/>
+          <a:chExt cx="0" cy="0"/>
+        </a:xfrm>
+      </p:grpSpPr>
+      <p:sp>
+        <p:nvSpPr>
+          <p:cNvPr id="2" name="Slide Image Placeholder 1"/>
+          <p:cNvSpPr>
+            <a:spLocks noGrp="1"/>
+          </p:cNvSpPr>
+          <p:nvPr>
+            <p:ph type="sldImg" idx="2"/>
+          </p:nvPr>
+        </p:nvSpPr>
+        <p:spPr/>
+      </p:sp>
+      <p:sp>
+        <p:nvSpPr>
+          <p:cNvPr id="3" name="Notes Placeholder 2"/>
+          <p:cNvSpPr>
+            <a:spLocks noGrp="1"/>
+          </p:cNvSpPr>
+          <p:nvPr>
+            <p:ph type="body" idx="3" sz="quarter"/>
+          </p:nvPr>
+        </p:nvSpPr>
+        <p:spPr/>
+        <p:txBody>
+          <a:bodyPr/>
+          <a:lstStyle/>
+          <a:p>
+            <a:r>
+              <a:t>PRESENTER 4 — R Raghav Srivatsav.</a:t>
+            </a:r>
+          </a:p>
+          <a:p>
+            <a:r>
+              <a:t>Tier C rigour: multi-seed significance, calibration (ECE 0.041), HPO, class-imbalance. Features significant; ConvMamba gain not robust (we report it honestly). Hand to Kumar Swamy.</a:t>
+            </a:r>
+          </a:p>
+        </p:txBody>
+      </p:sp>
+      <p:sp>
+        <p:nvSpPr>
+          <p:cNvPr id="4" name="Slide Number Placeholder 3"/>
+          <p:cNvSpPr>
+            <a:spLocks noGrp="1"/>
+          </p:cNvSpPr>
+          <p:nvPr>
+            <p:ph type="sldNum" idx="5" sz="quarter"/>
+          </p:nvPr>
+        </p:nvSpPr>
+        <p:spPr/>
+      </p:sp>
+    </p:spTree>
+  </p:cSld>
+  <p:clrMapOvr>
+    <a:masterClrMapping/>
+  </p:clrMapOvr>
+</p:notes>
+</file>
+
+<file path=ppt/notesSlides/notesSlide15.xml><?xml version="1.0" encoding="utf-8"?>
+<p:notes xmlns:a="http://schemas.openxmlformats.org/drawingml/2006/main" xmlns:p="http://schemas.openxmlformats.org/presentationml/2006/main" xmlns:r="http://schemas.openxmlformats.org/officeDocument/2006/relationships">
+  <p:cSld>
+    <p:spTree>
+      <p:nvGrpSpPr>
+        <p:cNvPr id="1" name=""/>
+        <p:cNvGrpSpPr/>
+        <p:nvPr/>
+      </p:nvGrpSpPr>
+      <p:grpSpPr>
+        <a:xfrm>
+          <a:off x="0" y="0"/>
+          <a:ext cx="0" cy="0"/>
+          <a:chOff x="0" y="0"/>
+          <a:chExt cx="0" cy="0"/>
+        </a:xfrm>
+      </p:grpSpPr>
+      <p:sp>
+        <p:nvSpPr>
+          <p:cNvPr id="2" name="Slide Image Placeholder 1"/>
+          <p:cNvSpPr>
+            <a:spLocks noGrp="1"/>
+          </p:cNvSpPr>
+          <p:nvPr>
+            <p:ph type="sldImg" idx="2"/>
+          </p:nvPr>
+        </p:nvSpPr>
+        <p:spPr/>
+      </p:sp>
+      <p:sp>
+        <p:nvSpPr>
+          <p:cNvPr id="3" name="Notes Placeholder 2"/>
+          <p:cNvSpPr>
+            <a:spLocks noGrp="1"/>
+          </p:cNvSpPr>
+          <p:nvPr>
+            <p:ph type="body" idx="3" sz="quarter"/>
+          </p:nvPr>
+        </p:nvSpPr>
+        <p:spPr/>
+        <p:txBody>
+          <a:bodyPr/>
+          <a:lstStyle/>
+          <a:p>
+            <a:r>
+              <a:t>PRESENTER 5 — Kumar Swamy C (Efficiency, Conclusion &amp; Q&amp;A).</a:t>
+            </a:r>
+          </a:p>
+          <a:p>
+            <a:r>
+              <a:t>Efficiency: O(L) vs O(L^2); at L=800 ~31x faster, ~750x fewer params.</a:t>
+            </a:r>
+          </a:p>
+        </p:txBody>
+      </p:sp>
+      <p:sp>
+        <p:nvSpPr>
+          <p:cNvPr id="4" name="Slide Number Placeholder 3"/>
+          <p:cNvSpPr>
+            <a:spLocks noGrp="1"/>
+          </p:cNvSpPr>
+          <p:nvPr>
+            <p:ph type="sldNum" idx="5" sz="quarter"/>
+          </p:nvPr>
+        </p:nvSpPr>
+        <p:spPr/>
+      </p:sp>
+    </p:spTree>
+  </p:cSld>
+  <p:clrMapOvr>
+    <a:masterClrMapping/>
+  </p:clrMapOvr>
+</p:notes>
+</file>
+
+<file path=ppt/notesSlides/notesSlide16.xml><?xml version="1.0" encoding="utf-8"?>
+<p:notes xmlns:a="http://schemas.openxmlformats.org/drawingml/2006/main" xmlns:p="http://schemas.openxmlformats.org/presentationml/2006/main" xmlns:r="http://schemas.openxmlformats.org/officeDocument/2006/relationships">
+  <p:cSld>
+    <p:spTree>
+      <p:nvGrpSpPr>
+        <p:cNvPr id="1" name=""/>
+        <p:cNvGrpSpPr/>
+        <p:nvPr/>
+      </p:nvGrpSpPr>
+      <p:grpSpPr>
+        <a:xfrm>
+          <a:off x="0" y="0"/>
+          <a:ext cx="0" cy="0"/>
+          <a:chOff x="0" y="0"/>
+          <a:chExt cx="0" cy="0"/>
+        </a:xfrm>
+      </p:grpSpPr>
+      <p:sp>
+        <p:nvSpPr>
+          <p:cNvPr id="2" name="Slide Image Placeholder 1"/>
+          <p:cNvSpPr>
+            <a:spLocks noGrp="1"/>
+          </p:cNvSpPr>
+          <p:nvPr>
+            <p:ph type="sldImg" idx="2"/>
+          </p:nvPr>
+        </p:nvSpPr>
+        <p:spPr/>
+      </p:sp>
+      <p:sp>
+        <p:nvSpPr>
+          <p:cNvPr id="3" name="Notes Placeholder 2"/>
+          <p:cNvSpPr>
+            <a:spLocks noGrp="1"/>
+          </p:cNvSpPr>
+          <p:nvPr>
+            <p:ph type="body" idx="3" sz="quarter"/>
+          </p:nvPr>
+        </p:nvSpPr>
+        <p:spPr/>
+        <p:txBody>
+          <a:bodyPr/>
+          <a:lstStyle/>
+          <a:p>
+            <a:r>
+              <a:t>PRESENTER 5 — Kumar Swamy C.</a:t>
+            </a:r>
+          </a:p>
+          <a:p>
+            <a:r>
+              <a:t>Conclusion: dataset + efficient SSM + significant feature finding; honest framing. Future work: spread-relative labelling, cost-aware backtest, walk-forward.</a:t>
+            </a:r>
+          </a:p>
+        </p:txBody>
+      </p:sp>
+      <p:sp>
+        <p:nvSpPr>
+          <p:cNvPr id="4" name="Slide Number Placeholder 3"/>
+          <p:cNvSpPr>
+            <a:spLocks noGrp="1"/>
+          </p:cNvSpPr>
+          <p:nvPr>
+            <p:ph type="sldNum" idx="5" sz="quarter"/>
+          </p:nvPr>
+        </p:nvSpPr>
+        <p:spPr/>
+      </p:sp>
+    </p:spTree>
+  </p:cSld>
+  <p:clrMapOvr>
+    <a:masterClrMapping/>
+  </p:clrMapOvr>
+</p:notes>
+</file>
+
+<file path=ppt/notesSlides/notesSlide17.xml><?xml version="1.0" encoding="utf-8"?>
+<p:notes xmlns:a="http://schemas.openxmlformats.org/drawingml/2006/main" xmlns:p="http://schemas.openxmlformats.org/presentationml/2006/main" xmlns:r="http://schemas.openxmlformats.org/officeDocument/2006/relationships">
+  <p:cSld>
+    <p:spTree>
+      <p:nvGrpSpPr>
+        <p:cNvPr id="1" name=""/>
+        <p:cNvGrpSpPr/>
+        <p:nvPr/>
+      </p:nvGrpSpPr>
+      <p:grpSpPr>
+        <a:xfrm>
+          <a:off x="0" y="0"/>
+          <a:ext cx="0" cy="0"/>
+          <a:chOff x="0" y="0"/>
+          <a:chExt cx="0" cy="0"/>
+        </a:xfrm>
+      </p:grpSpPr>
+      <p:sp>
+        <p:nvSpPr>
+          <p:cNvPr id="2" name="Slide Image Placeholder 1"/>
+          <p:cNvSpPr>
+            <a:spLocks noGrp="1"/>
+          </p:cNvSpPr>
+          <p:nvPr>
+            <p:ph type="sldImg" idx="2"/>
+          </p:nvPr>
+        </p:nvSpPr>
+        <p:spPr/>
+      </p:sp>
+      <p:sp>
+        <p:nvSpPr>
+          <p:cNvPr id="3" name="Notes Placeholder 2"/>
+          <p:cNvSpPr>
+            <a:spLocks noGrp="1"/>
+          </p:cNvSpPr>
+          <p:nvPr>
+            <p:ph type="body" idx="3" sz="quarter"/>
+          </p:nvPr>
+        </p:nvSpPr>
+        <p:spPr/>
+        <p:txBody>
+          <a:bodyPr/>
+          <a:lstStyle/>
+          <a:p>
+            <a:r>
+              <a:t>PRESENTER 5 — Kumar Swamy C.</a:t>
+            </a:r>
+          </a:p>
+          <a:p>
+            <a:r>
+              <a:t>Thank the panel and open for questions. The whole team fields Q&amp;A — route each question to whoever owns that section.</a:t>
+            </a:r>
+          </a:p>
+        </p:txBody>
+      </p:sp>
+      <p:sp>
+        <p:nvSpPr>
+          <p:cNvPr id="4" name="Slide Number Placeholder 3"/>
+          <p:cNvSpPr>
+            <a:spLocks noGrp="1"/>
+          </p:cNvSpPr>
+          <p:nvPr>
+            <p:ph type="sldNum" idx="5" sz="quarter"/>
+          </p:nvPr>
+        </p:nvSpPr>
+        <p:spPr/>
+      </p:sp>
+    </p:spTree>
+  </p:cSld>
+  <p:clrMapOvr>
+    <a:masterClrMapping/>
+  </p:clrMapOvr>
+</p:notes>
+</file>
+
+<file path=ppt/notesSlides/notesSlide2.xml><?xml version="1.0" encoding="utf-8"?>
+<p:notes xmlns:a="http://schemas.openxmlformats.org/drawingml/2006/main" xmlns:p="http://schemas.openxmlformats.org/presentationml/2006/main" xmlns:r="http://schemas.openxmlformats.org/officeDocument/2006/relationships">
+  <p:cSld>
+    <p:spTree>
+      <p:nvGrpSpPr>
+        <p:cNvPr id="1" name=""/>
+        <p:cNvGrpSpPr/>
+        <p:nvPr/>
+      </p:nvGrpSpPr>
+      <p:grpSpPr>
+        <a:xfrm>
+          <a:off x="0" y="0"/>
+          <a:ext cx="0" cy="0"/>
+          <a:chOff x="0" y="0"/>
+          <a:chExt cx="0" cy="0"/>
+        </a:xfrm>
+      </p:grpSpPr>
+      <p:sp>
+        <p:nvSpPr>
+          <p:cNvPr id="2" name="Slide Image Placeholder 1"/>
+          <p:cNvSpPr>
+            <a:spLocks noGrp="1"/>
+          </p:cNvSpPr>
+          <p:nvPr>
+            <p:ph type="sldImg" idx="2"/>
+          </p:nvPr>
+        </p:nvSpPr>
+        <p:spPr/>
+      </p:sp>
+      <p:sp>
+        <p:nvSpPr>
+          <p:cNvPr id="3" name="Notes Placeholder 2"/>
+          <p:cNvSpPr>
+            <a:spLocks noGrp="1"/>
+          </p:cNvSpPr>
+          <p:nvPr>
+            <p:ph type="body" idx="3" sz="quarter"/>
+          </p:nvPr>
+        </p:nvSpPr>
+        <p:spPr/>
+        <p:txBody>
+          <a:bodyPr/>
+          <a:lstStyle/>
+          <a:p>
+            <a:r>
+              <a:t>PRESENTER 1 — Sumanth G M.</a:t>
+            </a:r>
+          </a:p>
+          <a:p>
+            <a:r>
+              <a:t>Motivation: LOB has microstructure signal; prior work is developed-markets/FI-2010 only; Indian index futures unstudied; no clean dataset existed.</a:t>
+            </a:r>
+          </a:p>
+        </p:txBody>
+      </p:sp>
+      <p:sp>
+        <p:nvSpPr>
+          <p:cNvPr id="4" name="Slide Number Placeholder 3"/>
+          <p:cNvSpPr>
+            <a:spLocks noGrp="1"/>
+          </p:cNvSpPr>
+          <p:nvPr>
+            <p:ph type="sldNum" idx="5" sz="quarter"/>
+          </p:nvPr>
+        </p:nvSpPr>
+        <p:spPr/>
+      </p:sp>
+    </p:spTree>
+  </p:cSld>
+  <p:clrMapOvr>
+    <a:masterClrMapping/>
+  </p:clrMapOvr>
+</p:notes>
+</file>
+
+<file path=ppt/notesSlides/notesSlide3.xml><?xml version="1.0" encoding="utf-8"?>
+<p:notes xmlns:a="http://schemas.openxmlformats.org/drawingml/2006/main" xmlns:p="http://schemas.openxmlformats.org/presentationml/2006/main" xmlns:r="http://schemas.openxmlformats.org/officeDocument/2006/relationships">
+  <p:cSld>
+    <p:spTree>
+      <p:nvGrpSpPr>
+        <p:cNvPr id="1" name=""/>
+        <p:cNvGrpSpPr/>
+        <p:nvPr/>
+      </p:nvGrpSpPr>
+      <p:grpSpPr>
+        <a:xfrm>
+          <a:off x="0" y="0"/>
+          <a:ext cx="0" cy="0"/>
+          <a:chOff x="0" y="0"/>
+          <a:chExt cx="0" cy="0"/>
+        </a:xfrm>
+      </p:grpSpPr>
+      <p:sp>
+        <p:nvSpPr>
+          <p:cNvPr id="2" name="Slide Image Placeholder 1"/>
+          <p:cNvSpPr>
+            <a:spLocks noGrp="1"/>
+          </p:cNvSpPr>
+          <p:nvPr>
+            <p:ph type="sldImg" idx="2"/>
+          </p:nvPr>
+        </p:nvSpPr>
+        <p:spPr/>
+      </p:sp>
+      <p:sp>
+        <p:nvSpPr>
+          <p:cNvPr id="3" name="Notes Placeholder 2"/>
+          <p:cNvSpPr>
+            <a:spLocks noGrp="1"/>
+          </p:cNvSpPr>
+          <p:nvPr>
+            <p:ph type="body" idx="3" sz="quarter"/>
+          </p:nvPr>
+        </p:nvSpPr>
+        <p:spPr/>
+        <p:txBody>
+          <a:bodyPr/>
+          <a:lstStyle/>
+          <a:p>
+            <a:r>
+              <a:t>PRESENTER 1 — Sumanth G M.</a:t>
+            </a:r>
+          </a:p>
+          <a:p>
+            <a:r>
+              <a:t>State the objectives and the two research questions (efficient SSM? do features help?). Keep crisp.</a:t>
+            </a:r>
+          </a:p>
+        </p:txBody>
+      </p:sp>
+      <p:sp>
+        <p:nvSpPr>
+          <p:cNvPr id="4" name="Slide Number Placeholder 3"/>
+          <p:cNvSpPr>
+            <a:spLocks noGrp="1"/>
+          </p:cNvSpPr>
+          <p:nvPr>
+            <p:ph type="sldNum" idx="5" sz="quarter"/>
+          </p:nvPr>
+        </p:nvSpPr>
+        <p:spPr/>
+      </p:sp>
+    </p:spTree>
+  </p:cSld>
+  <p:clrMapOvr>
+    <a:masterClrMapping/>
+  </p:clrMapOvr>
+</p:notes>
+</file>
+
+<file path=ppt/notesSlides/notesSlide4.xml><?xml version="1.0" encoding="utf-8"?>
+<p:notes xmlns:a="http://schemas.openxmlformats.org/drawingml/2006/main" xmlns:p="http://schemas.openxmlformats.org/presentationml/2006/main" xmlns:r="http://schemas.openxmlformats.org/officeDocument/2006/relationships">
+  <p:cSld>
+    <p:spTree>
+      <p:nvGrpSpPr>
+        <p:cNvPr id="1" name=""/>
+        <p:cNvGrpSpPr/>
+        <p:nvPr/>
+      </p:nvGrpSpPr>
+      <p:grpSpPr>
+        <a:xfrm>
+          <a:off x="0" y="0"/>
+          <a:ext cx="0" cy="0"/>
+          <a:chOff x="0" y="0"/>
+          <a:chExt cx="0" cy="0"/>
+        </a:xfrm>
+      </p:grpSpPr>
+      <p:sp>
+        <p:nvSpPr>
+          <p:cNvPr id="2" name="Slide Image Placeholder 1"/>
+          <p:cNvSpPr>
+            <a:spLocks noGrp="1"/>
+          </p:cNvSpPr>
+          <p:nvPr>
+            <p:ph type="sldImg" idx="2"/>
+          </p:nvPr>
+        </p:nvSpPr>
+        <p:spPr/>
+      </p:sp>
+      <p:sp>
+        <p:nvSpPr>
+          <p:cNvPr id="3" name="Notes Placeholder 2"/>
+          <p:cNvSpPr>
+            <a:spLocks noGrp="1"/>
+          </p:cNvSpPr>
+          <p:nvPr>
+            <p:ph type="body" idx="3" sz="quarter"/>
+          </p:nvPr>
+        </p:nvSpPr>
+        <p:spPr/>
+        <p:txBody>
+          <a:bodyPr/>
+          <a:lstStyle/>
+          <a:p>
+            <a:r>
+              <a:t>PRESENTER 1 — Sumanth G M.</a:t>
+            </a:r>
+          </a:p>
+          <a:p>
+            <a:r>
+              <a:t>Related work in 4 names: FI-2010, DeepLOB, TLOB, Mamba/LOBCAST. Then: 'I'll hand over to Joseph for how we built our dataset.'</a:t>
+            </a:r>
+          </a:p>
+        </p:txBody>
+      </p:sp>
+      <p:sp>
+        <p:nvSpPr>
+          <p:cNvPr id="4" name="Slide Number Placeholder 3"/>
+          <p:cNvSpPr>
+            <a:spLocks noGrp="1"/>
+          </p:cNvSpPr>
+          <p:nvPr>
+            <p:ph type="sldNum" idx="5" sz="quarter"/>
+          </p:nvPr>
+        </p:nvSpPr>
+        <p:spPr/>
+      </p:sp>
+    </p:spTree>
+  </p:cSld>
+  <p:clrMapOvr>
+    <a:masterClrMapping/>
+  </p:clrMapOvr>
+</p:notes>
+</file>
+
+<file path=ppt/notesSlides/notesSlide5.xml><?xml version="1.0" encoding="utf-8"?>
+<p:notes xmlns:a="http://schemas.openxmlformats.org/drawingml/2006/main" xmlns:p="http://schemas.openxmlformats.org/presentationml/2006/main" xmlns:r="http://schemas.openxmlformats.org/officeDocument/2006/relationships">
+  <p:cSld>
+    <p:spTree>
+      <p:nvGrpSpPr>
+        <p:cNvPr id="1" name=""/>
+        <p:cNvGrpSpPr/>
+        <p:nvPr/>
+      </p:nvGrpSpPr>
+      <p:grpSpPr>
+        <a:xfrm>
+          <a:off x="0" y="0"/>
+          <a:ext cx="0" cy="0"/>
+          <a:chOff x="0" y="0"/>
+          <a:chExt cx="0" cy="0"/>
+        </a:xfrm>
+      </p:grpSpPr>
+      <p:sp>
+        <p:nvSpPr>
+          <p:cNvPr id="2" name="Slide Image Placeholder 1"/>
+          <p:cNvSpPr>
+            <a:spLocks noGrp="1"/>
+          </p:cNvSpPr>
+          <p:nvPr>
+            <p:ph type="sldImg" idx="2"/>
+          </p:nvPr>
+        </p:nvSpPr>
+        <p:spPr/>
+      </p:sp>
+      <p:sp>
+        <p:nvSpPr>
+          <p:cNvPr id="3" name="Notes Placeholder 2"/>
+          <p:cNvSpPr>
+            <a:spLocks noGrp="1"/>
+          </p:cNvSpPr>
+          <p:nvPr>
+            <p:ph type="body" idx="3" sz="quarter"/>
+          </p:nvPr>
+        </p:nvSpPr>
+        <p:spPr/>
+        <p:txBody>
+          <a:bodyPr/>
+          <a:lstStyle/>
+          <a:p>
+            <a:r>
+              <a:t>PRESENTER 2 — Joseph Raj (Data Engineering &amp; Dataset). YOUR STRONGEST SLIDE.</a:t>
+            </a:r>
+          </a:p>
+          <a:p>
+            <a:r>
+              <a:t>Reverse-engineered Dhan binary feed (1992B/664B), EC2-&gt;Parquet-&gt;S3 pipeline, front-month stitch. ~1.1M events. This is the core contribution.</a:t>
+            </a:r>
+          </a:p>
+        </p:txBody>
+      </p:sp>
+      <p:sp>
+        <p:nvSpPr>
+          <p:cNvPr id="4" name="Slide Number Placeholder 3"/>
+          <p:cNvSpPr>
+            <a:spLocks noGrp="1"/>
+          </p:cNvSpPr>
+          <p:nvPr>
+            <p:ph type="sldNum" idx="5" sz="quarter"/>
+          </p:nvPr>
+        </p:nvSpPr>
+        <p:spPr/>
+      </p:sp>
+    </p:spTree>
+  </p:cSld>
+  <p:clrMapOvr>
+    <a:masterClrMapping/>
+  </p:clrMapOvr>
+</p:notes>
+</file>
+
+<file path=ppt/notesSlides/notesSlide6.xml><?xml version="1.0" encoding="utf-8"?>
+<p:notes xmlns:a="http://schemas.openxmlformats.org/drawingml/2006/main" xmlns:p="http://schemas.openxmlformats.org/presentationml/2006/main" xmlns:r="http://schemas.openxmlformats.org/officeDocument/2006/relationships">
+  <p:cSld>
+    <p:spTree>
+      <p:nvGrpSpPr>
+        <p:cNvPr id="1" name=""/>
+        <p:cNvGrpSpPr/>
+        <p:nvPr/>
+      </p:nvGrpSpPr>
+      <p:grpSpPr>
+        <a:xfrm>
+          <a:off x="0" y="0"/>
+          <a:ext cx="0" cy="0"/>
+          <a:chOff x="0" y="0"/>
+          <a:chExt cx="0" cy="0"/>
+        </a:xfrm>
+      </p:grpSpPr>
+      <p:sp>
+        <p:nvSpPr>
+          <p:cNvPr id="2" name="Slide Image Placeholder 1"/>
+          <p:cNvSpPr>
+            <a:spLocks noGrp="1"/>
+          </p:cNvSpPr>
+          <p:nvPr>
+            <p:ph type="sldImg" idx="2"/>
+          </p:nvPr>
+        </p:nvSpPr>
+        <p:spPr/>
+      </p:sp>
+      <p:sp>
+        <p:nvSpPr>
+          <p:cNvPr id="3" name="Notes Placeholder 2"/>
+          <p:cNvSpPr>
+            <a:spLocks noGrp="1"/>
+          </p:cNvSpPr>
+          <p:nvPr>
+            <p:ph type="body" idx="3" sz="quarter"/>
+          </p:nvPr>
+        </p:nvSpPr>
+        <p:spPr/>
+        <p:txBody>
+          <a:bodyPr/>
+          <a:lstStyle/>
+          <a:p>
+            <a:r>
+              <a:t>PRESENTER 2 — Joseph Raj.</a:t>
+            </a:r>
+          </a:p>
+          <a:p>
+            <a:r>
+              <a:t>Datasets: FI-2010 spec + engineered NSE spec; first 10 levels = 40 features = FI-2010 layout -&gt; models transfer unchanged. Be upfront: ~0.4s snapshot cadence, not tick-level.</a:t>
+            </a:r>
+          </a:p>
+        </p:txBody>
+      </p:sp>
+      <p:sp>
+        <p:nvSpPr>
+          <p:cNvPr id="4" name="Slide Number Placeholder 3"/>
+          <p:cNvSpPr>
+            <a:spLocks noGrp="1"/>
+          </p:cNvSpPr>
+          <p:nvPr>
+            <p:ph type="sldNum" idx="5" sz="quarter"/>
+          </p:nvPr>
+        </p:nvSpPr>
+        <p:spPr/>
+      </p:sp>
+    </p:spTree>
+  </p:cSld>
+  <p:clrMapOvr>
+    <a:masterClrMapping/>
+  </p:clrMapOvr>
+</p:notes>
+</file>
+
+<file path=ppt/notesSlides/notesSlide7.xml><?xml version="1.0" encoding="utf-8"?>
+<p:notes xmlns:a="http://schemas.openxmlformats.org/drawingml/2006/main" xmlns:p="http://schemas.openxmlformats.org/presentationml/2006/main" xmlns:r="http://schemas.openxmlformats.org/officeDocument/2006/relationships">
+  <p:cSld>
+    <p:spTree>
+      <p:nvGrpSpPr>
+        <p:cNvPr id="1" name=""/>
+        <p:cNvGrpSpPr/>
+        <p:nvPr/>
+      </p:nvGrpSpPr>
+      <p:grpSpPr>
+        <a:xfrm>
+          <a:off x="0" y="0"/>
+          <a:ext cx="0" cy="0"/>
+          <a:chOff x="0" y="0"/>
+          <a:chExt cx="0" cy="0"/>
+        </a:xfrm>
+      </p:grpSpPr>
+      <p:sp>
+        <p:nvSpPr>
+          <p:cNvPr id="2" name="Slide Image Placeholder 1"/>
+          <p:cNvSpPr>
+            <a:spLocks noGrp="1"/>
+          </p:cNvSpPr>
+          <p:nvPr>
+            <p:ph type="sldImg" idx="2"/>
+          </p:nvPr>
+        </p:nvSpPr>
+        <p:spPr/>
+      </p:sp>
+      <p:sp>
+        <p:nvSpPr>
+          <p:cNvPr id="3" name="Notes Placeholder 2"/>
+          <p:cNvSpPr>
+            <a:spLocks noGrp="1"/>
+          </p:cNvSpPr>
+          <p:nvPr>
+            <p:ph type="body" idx="3" sz="quarter"/>
+          </p:nvPr>
+        </p:nvSpPr>
+        <p:spPr/>
+        <p:txBody>
+          <a:bodyPr/>
+          <a:lstStyle/>
+          <a:p>
+            <a:r>
+              <a:t>PRESENTER 2 — Joseph Raj.</a:t>
+            </a:r>
+          </a:p>
+          <a:p>
+            <a:r>
+              <a:t>EDA: Stationary class shrinks 19%-&gt;4% with horizon; spread ~3.3 bps; regular ~2.5Hz cadence.</a:t>
+            </a:r>
+          </a:p>
+        </p:txBody>
+      </p:sp>
+      <p:sp>
+        <p:nvSpPr>
+          <p:cNvPr id="4" name="Slide Number Placeholder 3"/>
+          <p:cNvSpPr>
+            <a:spLocks noGrp="1"/>
+          </p:cNvSpPr>
+          <p:nvPr>
+            <p:ph type="sldNum" idx="5" sz="quarter"/>
+          </p:nvPr>
+        </p:nvSpPr>
+        <p:spPr/>
+      </p:sp>
+    </p:spTree>
+  </p:cSld>
+  <p:clrMapOvr>
+    <a:masterClrMapping/>
+  </p:clrMapOvr>
+</p:notes>
+</file>
+
+<file path=ppt/notesSlides/notesSlide8.xml><?xml version="1.0" encoding="utf-8"?>
+<p:notes xmlns:a="http://schemas.openxmlformats.org/drawingml/2006/main" xmlns:p="http://schemas.openxmlformats.org/presentationml/2006/main" xmlns:r="http://schemas.openxmlformats.org/officeDocument/2006/relationships">
+  <p:cSld>
+    <p:spTree>
+      <p:nvGrpSpPr>
+        <p:cNvPr id="1" name=""/>
+        <p:cNvGrpSpPr/>
+        <p:nvPr/>
+      </p:nvGrpSpPr>
+      <p:grpSpPr>
+        <a:xfrm>
+          <a:off x="0" y="0"/>
+          <a:ext cx="0" cy="0"/>
+          <a:chOff x="0" y="0"/>
+          <a:chExt cx="0" cy="0"/>
+        </a:xfrm>
+      </p:grpSpPr>
+      <p:sp>
+        <p:nvSpPr>
+          <p:cNvPr id="2" name="Slide Image Placeholder 1"/>
+          <p:cNvSpPr>
+            <a:spLocks noGrp="1"/>
+          </p:cNvSpPr>
+          <p:nvPr>
+            <p:ph type="sldImg" idx="2"/>
+          </p:nvPr>
+        </p:nvSpPr>
+        <p:spPr/>
+      </p:sp>
+      <p:sp>
+        <p:nvSpPr>
+          <p:cNvPr id="3" name="Notes Placeholder 2"/>
+          <p:cNvSpPr>
+            <a:spLocks noGrp="1"/>
+          </p:cNvSpPr>
+          <p:nvPr>
+            <p:ph type="body" idx="3" sz="quarter"/>
+          </p:nvPr>
+        </p:nvSpPr>
+        <p:spPr/>
+        <p:txBody>
+          <a:bodyPr/>
+          <a:lstStyle/>
+          <a:p>
+            <a:r>
+              <a:t>PRESENTER 2 — Joseph Raj.</a:t>
+            </a:r>
+          </a:p>
+          <a:p>
+            <a:r>
+              <a:t>Preprocessing pipeline + labelling (alpha=1e-5) + engineered microstructure features. Hand to Abhishek for the models.</a:t>
+            </a:r>
+          </a:p>
+        </p:txBody>
+      </p:sp>
+      <p:sp>
+        <p:nvSpPr>
+          <p:cNvPr id="4" name="Slide Number Placeholder 3"/>
+          <p:cNvSpPr>
+            <a:spLocks noGrp="1"/>
+          </p:cNvSpPr>
+          <p:nvPr>
+            <p:ph type="sldNum" idx="5" sz="quarter"/>
+          </p:nvPr>
+        </p:nvSpPr>
+        <p:spPr/>
+      </p:sp>
+    </p:spTree>
+  </p:cSld>
+  <p:clrMapOvr>
+    <a:masterClrMapping/>
+  </p:clrMapOvr>
+</p:notes>
+</file>
+
+<file path=ppt/notesSlides/notesSlide9.xml><?xml version="1.0" encoding="utf-8"?>
+<p:notes xmlns:a="http://schemas.openxmlformats.org/drawingml/2006/main" xmlns:p="http://schemas.openxmlformats.org/presentationml/2006/main" xmlns:r="http://schemas.openxmlformats.org/officeDocument/2006/relationships">
+  <p:cSld>
+    <p:spTree>
+      <p:nvGrpSpPr>
+        <p:cNvPr id="1" name=""/>
+        <p:cNvGrpSpPr/>
+        <p:nvPr/>
+      </p:nvGrpSpPr>
+      <p:grpSpPr>
+        <a:xfrm>
+          <a:off x="0" y="0"/>
+          <a:ext cx="0" cy="0"/>
+          <a:chOff x="0" y="0"/>
+          <a:chExt cx="0" cy="0"/>
+        </a:xfrm>
+      </p:grpSpPr>
+      <p:sp>
+        <p:nvSpPr>
+          <p:cNvPr id="2" name="Slide Image Placeholder 1"/>
+          <p:cNvSpPr>
+            <a:spLocks noGrp="1"/>
+          </p:cNvSpPr>
+          <p:nvPr>
+            <p:ph type="sldImg" idx="2"/>
+          </p:nvPr>
+        </p:nvSpPr>
+        <p:spPr/>
+      </p:sp>
+      <p:sp>
+        <p:nvSpPr>
+          <p:cNvPr id="3" name="Notes Placeholder 2"/>
+          <p:cNvSpPr>
+            <a:spLocks noGrp="1"/>
+          </p:cNvSpPr>
+          <p:nvPr>
+            <p:ph type="body" idx="3" sz="quarter"/>
+          </p:nvPr>
+        </p:nvSpPr>
+        <p:spPr/>
+        <p:txBody>
+          <a:bodyPr/>
+          <a:lstStyle/>
+          <a:p>
+            <a:r>
+              <a:t>PRESENTER 3 — Abhishek Kumar (Models &amp; Reproduction).</a:t>
+            </a:r>
+          </a:p>
+          <a:p>
+            <a:r>
+              <a:t>Baselines (DeepLOB/MLPLOB/TLOB) + proposed MambaLOB (selective SSM, O(L)) + ConvMambaLOB. One contract for all.</a:t>
+            </a:r>
+          </a:p>
+        </p:txBody>
+      </p:sp>
+      <p:sp>
+        <p:nvSpPr>
+          <p:cNvPr id="4" name="Slide Number Placeholder 3"/>
+          <p:cNvSpPr>
+            <a:spLocks noGrp="1"/>
+          </p:cNvSpPr>
+          <p:nvPr>
+            <p:ph type="sldNum" idx="5" sz="quarter"/>
+          </p:nvPr>
+        </p:nvSpPr>
+        <p:spPr/>
+      </p:sp>
+    </p:spTree>
+  </p:cSld>
+  <p:clrMapOvr>
+    <a:masterClrMapping/>
+  </p:clrMapOvr>
+</p:notes>
 </file>
 
 <file path=ppt/slideLayouts/slideLayout1.xml><?xml version="1.0" encoding="utf-8"?>
@@ -6716,4 +8341,324 @@
   </a:objectDefaults>
   <a:extraClrSchemeLst/>
 </a:theme>
+</file>
+
+<file path=ppt/theme/theme2.xml><?xml version="1.0" encoding="utf-8"?>
+<a:theme xmlns:a="http://schemas.openxmlformats.org/drawingml/2006/main" name="Office Theme">
+  <a:themeElements>
+    <a:clrScheme name="Office">
+      <a:dk1>
+        <a:sysClr val="windowText" lastClr="000000"/>
+      </a:dk1>
+      <a:lt1>
+        <a:sysClr val="window" lastClr="FFFFFF"/>
+      </a:lt1>
+      <a:dk2>
+        <a:srgbClr val="1F497D"/>
+      </a:dk2>
+      <a:lt2>
+        <a:srgbClr val="EEECE1"/>
+      </a:lt2>
+      <a:accent1>
+        <a:srgbClr val="4F81BD"/>
+      </a:accent1>
+      <a:accent2>
+        <a:srgbClr val="C0504D"/>
+      </a:accent2>
+      <a:accent3>
+        <a:srgbClr val="9BBB59"/>
+      </a:accent3>
+      <a:accent4>
+        <a:srgbClr val="8064A2"/>
+      </a:accent4>
+      <a:accent5>
+        <a:srgbClr val="4BACC6"/>
+      </a:accent5>
+      <a:accent6>
+        <a:srgbClr val="F79646"/>
+      </a:accent6>
+      <a:hlink>
+        <a:srgbClr val="0000FF"/>
+      </a:hlink>
+      <a:folHlink>
+        <a:srgbClr val="800080"/>
+      </a:folHlink>
+    </a:clrScheme>
+    <a:fontScheme name="Office">
+      <a:majorFont>
+        <a:latin typeface="Calibri"/>
+        <a:ea typeface=""/>
+        <a:cs typeface=""/>
+        <a:font script="Jpan" typeface="ＭＳ Ｐゴシック"/>
+        <a:font script="Hang" typeface="맑은 고딕"/>
+        <a:font script="Hans" typeface="宋体"/>
+        <a:font script="Hant" typeface="新細明體"/>
+        <a:font script="Arab" typeface="Times New Roman"/>
+        <a:font script="Hebr" typeface="Times New Roman"/>
+        <a:font script="Thai" typeface="Angsana New"/>
+        <a:font script="Ethi" typeface="Nyala"/>
+        <a:font script="Beng" typeface="Vrinda"/>
+        <a:font script="Gujr" typeface="Shruti"/>
+        <a:font script="Khmr" typeface="MoolBoran"/>
+        <a:font script="Knda" typeface="Tunga"/>
+        <a:font script="Guru" typeface="Raavi"/>
+        <a:font script="Cans" typeface="Euphemia"/>
+        <a:font script="Cher" typeface="Plantagenet Cherokee"/>
+        <a:font script="Yiii" typeface="Microsoft Yi Baiti"/>
+        <a:font script="Tibt" typeface="Microsoft Himalaya"/>
+        <a:font script="Thaa" typeface="MV Boli"/>
+        <a:font script="Deva" typeface="Mangal"/>
+        <a:font script="Telu" typeface="Gautami"/>
+        <a:font script="Taml" typeface="Latha"/>
+        <a:font script="Syrc" typeface="Estrangelo Edessa"/>
+        <a:font script="Orya" typeface="Kalinga"/>
+        <a:font script="Mlym" typeface="Kartika"/>
+        <a:font script="Laoo" typeface="DokChampa"/>
+        <a:font script="Sinh" typeface="Iskoola Pota"/>
+        <a:font script="Mong" typeface="Mongolian Baiti"/>
+        <a:font script="Viet" typeface="Times New Roman"/>
+        <a:font script="Uigh" typeface="Microsoft Uighur"/>
+        <a:font script="Geor" typeface="Sylfaen"/>
+      </a:majorFont>
+      <a:minorFont>
+        <a:latin typeface="Calibri"/>
+        <a:ea typeface=""/>
+        <a:cs typeface=""/>
+        <a:font script="Jpan" typeface="ＭＳ Ｐゴシック"/>
+        <a:font script="Hang" typeface="맑은 고딕"/>
+        <a:font script="Hans" typeface="宋体"/>
+        <a:font script="Hant" typeface="新細明體"/>
+        <a:font script="Arab" typeface="Arial"/>
+        <a:font script="Hebr" typeface="Arial"/>
+        <a:font script="Thai" typeface="Cordia New"/>
+        <a:font script="Ethi" typeface="Nyala"/>
+        <a:font script="Beng" typeface="Vrinda"/>
+        <a:font script="Gujr" typeface="Shruti"/>
+        <a:font script="Khmr" typeface="DaunPenh"/>
+        <a:font script="Knda" typeface="Tunga"/>
+        <a:font script="Guru" typeface="Raavi"/>
+        <a:font script="Cans" typeface="Euphemia"/>
+        <a:font script="Cher" typeface="Plantagenet Cherokee"/>
+        <a:font script="Yiii" typeface="Microsoft Yi Baiti"/>
+        <a:font script="Tibt" typeface="Microsoft Himalaya"/>
+        <a:font script="Thaa" typeface="MV Boli"/>
+        <a:font script="Deva" typeface="Mangal"/>
+        <a:font script="Telu" typeface="Gautami"/>
+        <a:font script="Taml" typeface="Latha"/>
+        <a:font script="Syrc" typeface="Estrangelo Edessa"/>
+        <a:font script="Orya" typeface="Kalinga"/>
+        <a:font script="Mlym" typeface="Kartika"/>
+        <a:font script="Laoo" typeface="DokChampa"/>
+        <a:font script="Sinh" typeface="Iskoola Pota"/>
+        <a:font script="Mong" typeface="Mongolian Baiti"/>
+        <a:font script="Viet" typeface="Arial"/>
+        <a:font script="Uigh" typeface="Microsoft Uighur"/>
+        <a:font script="Geor" typeface="Sylfaen"/>
+      </a:minorFont>
+    </a:fontScheme>
+    <a:fmtScheme name="Office">
+      <a:fillStyleLst>
+        <a:solidFill>
+          <a:schemeClr val="phClr"/>
+        </a:solidFill>
+        <a:gradFill rotWithShape="1">
+          <a:gsLst>
+            <a:gs pos="0">
+              <a:schemeClr val="phClr">
+                <a:tint val="50000"/>
+                <a:satMod val="300000"/>
+              </a:schemeClr>
+            </a:gs>
+            <a:gs pos="35000">
+              <a:schemeClr val="phClr">
+                <a:tint val="37000"/>
+                <a:satMod val="300000"/>
+              </a:schemeClr>
+            </a:gs>
+            <a:gs pos="100000">
+              <a:schemeClr val="phClr">
+                <a:tint val="15000"/>
+                <a:satMod val="350000"/>
+              </a:schemeClr>
+            </a:gs>
+          </a:gsLst>
+          <a:lin ang="16200000" scaled="1"/>
+        </a:gradFill>
+        <a:gradFill rotWithShape="1">
+          <a:gsLst>
+            <a:gs pos="0">
+              <a:schemeClr val="phClr">
+                <a:tint val="100000"/>
+                <a:shade val="100000"/>
+                <a:satMod val="130000"/>
+              </a:schemeClr>
+            </a:gs>
+            <a:gs pos="100000">
+              <a:schemeClr val="phClr">
+                <a:tint val="50000"/>
+                <a:shade val="100000"/>
+                <a:satMod val="350000"/>
+              </a:schemeClr>
+            </a:gs>
+          </a:gsLst>
+          <a:lin ang="16200000" scaled="0"/>
+        </a:gradFill>
+      </a:fillStyleLst>
+      <a:lnStyleLst>
+        <a:ln w="9525" cap="flat" cmpd="sng" algn="ctr">
+          <a:solidFill>
+            <a:schemeClr val="phClr">
+              <a:shade val="95000"/>
+              <a:satMod val="105000"/>
+            </a:schemeClr>
+          </a:solidFill>
+          <a:prstDash val="solid"/>
+        </a:ln>
+        <a:ln w="25400" cap="flat" cmpd="sng" algn="ctr">
+          <a:solidFill>
+            <a:schemeClr val="phClr"/>
+          </a:solidFill>
+          <a:prstDash val="solid"/>
+        </a:ln>
+        <a:ln w="38100" cap="flat" cmpd="sng" algn="ctr">
+          <a:solidFill>
+            <a:schemeClr val="phClr"/>
+          </a:solidFill>
+          <a:prstDash val="solid"/>
+        </a:ln>
+      </a:lnStyleLst>
+      <a:effectStyleLst>
+        <a:effectStyle>
+          <a:effectLst>
+            <a:outerShdw blurRad="40000" dist="20000" dir="5400000" rotWithShape="0">
+              <a:srgbClr val="000000">
+                <a:alpha val="38000"/>
+              </a:srgbClr>
+            </a:outerShdw>
+          </a:effectLst>
+        </a:effectStyle>
+        <a:effectStyle>
+          <a:effectLst>
+            <a:outerShdw blurRad="40000" dist="23000" dir="5400000" rotWithShape="0">
+              <a:srgbClr val="000000">
+                <a:alpha val="35000"/>
+              </a:srgbClr>
+            </a:outerShdw>
+          </a:effectLst>
+        </a:effectStyle>
+        <a:effectStyle>
+          <a:effectLst>
+            <a:outerShdw blurRad="40000" dist="23000" dir="5400000" rotWithShape="0">
+              <a:srgbClr val="000000">
+                <a:alpha val="35000"/>
+              </a:srgbClr>
+            </a:outerShdw>
+          </a:effectLst>
+          <a:scene3d>
+            <a:camera prst="orthographicFront">
+              <a:rot lat="0" lon="0" rev="0"/>
+            </a:camera>
+            <a:lightRig rig="threePt" dir="t">
+              <a:rot lat="0" lon="0" rev="1200000"/>
+            </a:lightRig>
+          </a:scene3d>
+          <a:sp3d>
+            <a:bevelT w="63500" h="25400"/>
+          </a:sp3d>
+        </a:effectStyle>
+      </a:effectStyleLst>
+      <a:bgFillStyleLst>
+        <a:solidFill>
+          <a:schemeClr val="phClr"/>
+        </a:solidFill>
+        <a:gradFill rotWithShape="1">
+          <a:gsLst>
+            <a:gs pos="0">
+              <a:schemeClr val="phClr">
+                <a:tint val="40000"/>
+                <a:satMod val="350000"/>
+              </a:schemeClr>
+            </a:gs>
+            <a:gs pos="40000">
+              <a:schemeClr val="phClr">
+                <a:tint val="45000"/>
+                <a:shade val="99000"/>
+                <a:satMod val="350000"/>
+              </a:schemeClr>
+            </a:gs>
+            <a:gs pos="100000">
+              <a:schemeClr val="phClr">
+                <a:shade val="20000"/>
+                <a:satMod val="255000"/>
+              </a:schemeClr>
+            </a:gs>
+          </a:gsLst>
+          <a:path path="circle">
+            <a:fillToRect l="50000" t="-80000" r="50000" b="180000"/>
+          </a:path>
+        </a:gradFill>
+        <a:gradFill rotWithShape="1">
+          <a:gsLst>
+            <a:gs pos="0">
+              <a:schemeClr val="phClr">
+                <a:tint val="80000"/>
+                <a:satMod val="300000"/>
+              </a:schemeClr>
+            </a:gs>
+            <a:gs pos="100000">
+              <a:schemeClr val="phClr">
+                <a:shade val="30000"/>
+                <a:satMod val="200000"/>
+              </a:schemeClr>
+            </a:gs>
+          </a:gsLst>
+          <a:path path="circle">
+            <a:fillToRect l="50000" t="50000" r="50000" b="50000"/>
+          </a:path>
+        </a:gradFill>
+      </a:bgFillStyleLst>
+    </a:fmtScheme>
+  </a:themeElements>
+  <a:objectDefaults>
+    <a:spDef>
+      <a:spPr/>
+      <a:bodyPr/>
+      <a:lstStyle/>
+      <a:style>
+        <a:lnRef idx="1">
+          <a:schemeClr val="accent1"/>
+        </a:lnRef>
+        <a:fillRef idx="3">
+          <a:schemeClr val="accent1"/>
+        </a:fillRef>
+        <a:effectRef idx="2">
+          <a:schemeClr val="accent1"/>
+        </a:effectRef>
+        <a:fontRef idx="minor">
+          <a:schemeClr val="lt1"/>
+        </a:fontRef>
+      </a:style>
+    </a:spDef>
+    <a:lnDef>
+      <a:spPr/>
+      <a:bodyPr/>
+      <a:lstStyle/>
+      <a:style>
+        <a:lnRef idx="2">
+          <a:schemeClr val="accent1"/>
+        </a:lnRef>
+        <a:fillRef idx="0">
+          <a:schemeClr val="accent1"/>
+        </a:fillRef>
+        <a:effectRef idx="1">
+          <a:schemeClr val="accent1"/>
+        </a:effectRef>
+        <a:fontRef idx="minor">
+          <a:schemeClr val="tx1"/>
+        </a:fontRef>
+      </a:style>
+    </a:lnDef>
+  </a:objectDefaults>
+  <a:extraClrSchemeLst/>
+</a:theme>
 </file>
</xml_diff>

<commit_message>
docs/presentation: add Background & Project Overview slide (slide 2)
High-level LOB-space context + project abstract + roadmap, slotted after the
title and before Motivation (detailed survey stays in Related Work). Deck now
18 slides; presenter split rebalanced to 5/4/3/3/3 (P1 slides 1-5) in both the
speaker notes and the prep-guide table.

Co-Authored-By: Claude Opus 4.8 (1M context) <noreply@anthropic.com>
</commit_message>
<xml_diff>
--- a/docs/presentation/Capstone_Final_Presentation.pptx
+++ b/docs/presentation/Capstone_Final_Presentation.pptx
@@ -22,6 +22,7 @@
     <p:sldId id="270" r:id="rId21"/>
     <p:sldId id="271" r:id="rId22"/>
     <p:sldId id="272" r:id="rId23"/>
+    <p:sldId id="273" r:id="rId24"/>
   </p:sldIdLst>
   <p:sldSz cx="12191695" cy="6858000" type="screen4x3"/>
   <p:notesSz cx="6858000" cy="9144000"/>
@@ -518,12 +519,12 @@
           <a:lstStyle/>
           <a:p>
             <a:r>
-              <a:t>PRESENTER 1 — Sumanth G M (Intro &amp; Motivation).</a:t>
-            </a:r>
-          </a:p>
-          <a:p>
-            <a:r>
-              <a:t>Welcome the panel; state the title and the one-line problem: predict short-horizon mid-price direction from LOB data. Hand off after Related Work to Joseph.</a:t>
+              <a:t>PRESENTER 1 — Sumanth G M (Intro &amp; Overview).</a:t>
+            </a:r>
+          </a:p>
+          <a:p>
+            <a:r>
+              <a:t>Welcome the panel; state the title and the one-line problem: predict short-horizon mid-price direction from LOB data.</a:t>
             </a:r>
           </a:p>
         </p:txBody>
@@ -593,12 +594,12 @@
           <a:lstStyle/>
           <a:p>
             <a:r>
-              <a:t>PRESENTER 3 — Abhishek Kumar.</a:t>
-            </a:r>
-          </a:p>
-          <a:p>
-            <a:r>
-              <a:t>FI-2010 reproduction validates the pipeline: DeepLOB ~= paper, TLOB in SOTA range.</a:t>
+              <a:t>PRESENTER 3 — Abhishek Kumar (Models &amp; Reproduction).</a:t>
+            </a:r>
+          </a:p>
+          <a:p>
+            <a:r>
+              <a:t>Baselines (DeepLOB/MLPLOB/TLOB) + proposed MambaLOB (selective SSM, O(L)) + ConvMambaLOB. One contract for all.</a:t>
             </a:r>
           </a:p>
         </p:txBody>
@@ -673,7 +674,7 @@
           </a:p>
           <a:p>
             <a:r>
-              <a:t>NSE transfer: all beat baselines (signal exists); below FI-2010 (expected); TLOB leads; MambaLOB beats DeepLOB on NIFTY at 1/27 params. Hand to Raghav for Phase-2.</a:t>
+              <a:t>FI-2010 reproduction validates the pipeline: DeepLOB ~= paper, TLOB in SOTA range.</a:t>
             </a:r>
           </a:p>
         </p:txBody>
@@ -743,12 +744,12 @@
           <a:lstStyle/>
           <a:p>
             <a:r>
-              <a:t>PRESENTER 4 — R Raghav Srivatsav (Phase-2 DS contributions).</a:t>
-            </a:r>
-          </a:p>
-          <a:p>
-            <a:r>
-              <a:t>Tier A: microstructure features give a SIGNIFICANT gain (+0.084 wF1, p=0.001).</a:t>
+              <a:t>PRESENTER 3 — Abhishek Kumar.</a:t>
+            </a:r>
+          </a:p>
+          <a:p>
+            <a:r>
+              <a:t>NSE transfer: all beat baselines (signal exists); below FI-2010 (expected); TLOB leads; MambaLOB beats DeepLOB on NIFTY at 1/27 params. Hand to Raghav for Phase-2.</a:t>
             </a:r>
           </a:p>
         </p:txBody>
@@ -818,12 +819,12 @@
           <a:lstStyle/>
           <a:p>
             <a:r>
-              <a:t>PRESENTER 4 — R Raghav Srivatsav.</a:t>
-            </a:r>
-          </a:p>
-          <a:p>
-            <a:r>
-              <a:t>Tier B: ConvMambaLOB best of ours, ~90% of TLOB at 12.5x fewer params. Honest: efficiency trade-off, not accuracy win.</a:t>
+              <a:t>PRESENTER 4 — R Raghav Srivatsav (Phase-2 DS contributions).</a:t>
+            </a:r>
+          </a:p>
+          <a:p>
+            <a:r>
+              <a:t>Tier A: microstructure features give a SIGNIFICANT gain (+0.084 wF1, p=0.001).</a:t>
             </a:r>
           </a:p>
         </p:txBody>
@@ -898,7 +899,7 @@
           </a:p>
           <a:p>
             <a:r>
-              <a:t>Tier C rigour: multi-seed significance, calibration (ECE 0.041), HPO, class-imbalance. Features significant; ConvMamba gain not robust (we report it honestly). Hand to Kumar Swamy.</a:t>
+              <a:t>Tier B: ConvMambaLOB best of ours, ~90% of TLOB at 12.5x fewer params. Honest: efficiency trade-off, not accuracy win.</a:t>
             </a:r>
           </a:p>
         </p:txBody>
@@ -968,12 +969,12 @@
           <a:lstStyle/>
           <a:p>
             <a:r>
-              <a:t>PRESENTER 5 — Kumar Swamy C (Efficiency, Conclusion &amp; Q&amp;A).</a:t>
-            </a:r>
-          </a:p>
-          <a:p>
-            <a:r>
-              <a:t>Efficiency: O(L) vs O(L^2); at L=800 ~31x faster, ~750x fewer params.</a:t>
+              <a:t>PRESENTER 4 — R Raghav Srivatsav.</a:t>
+            </a:r>
+          </a:p>
+          <a:p>
+            <a:r>
+              <a:t>Tier C rigour: multi-seed significance, calibration (ECE 0.041), HPO, class-imbalance. Features significant; ConvMamba gain not robust (we report it honestly). Hand to Kumar Swamy.</a:t>
             </a:r>
           </a:p>
         </p:txBody>
@@ -1043,12 +1044,12 @@
           <a:lstStyle/>
           <a:p>
             <a:r>
-              <a:t>PRESENTER 5 — Kumar Swamy C.</a:t>
-            </a:r>
-          </a:p>
-          <a:p>
-            <a:r>
-              <a:t>Conclusion: dataset + efficient SSM + significant feature finding; honest framing. Future work: spread-relative labelling, cost-aware backtest, walk-forward.</a:t>
+              <a:t>PRESENTER 5 — Kumar Swamy C (Efficiency, Conclusion &amp; Q&amp;A).</a:t>
+            </a:r>
+          </a:p>
+          <a:p>
+            <a:r>
+              <a:t>Efficiency: O(L) vs O(L^2); at L=800 ~31x faster, ~750x fewer params.</a:t>
             </a:r>
           </a:p>
         </p:txBody>
@@ -1123,6 +1124,81 @@
           </a:p>
           <a:p>
             <a:r>
+              <a:t>Conclusion: dataset + efficient SSM + significant feature finding; honest framing. Future work: spread-relative labelling, cost-aware backtest, walk-forward.</a:t>
+            </a:r>
+          </a:p>
+        </p:txBody>
+      </p:sp>
+      <p:sp>
+        <p:nvSpPr>
+          <p:cNvPr id="4" name="Slide Number Placeholder 3"/>
+          <p:cNvSpPr>
+            <a:spLocks noGrp="1"/>
+          </p:cNvSpPr>
+          <p:nvPr>
+            <p:ph type="sldNum" idx="5" sz="quarter"/>
+          </p:nvPr>
+        </p:nvSpPr>
+        <p:spPr/>
+      </p:sp>
+    </p:spTree>
+  </p:cSld>
+  <p:clrMapOvr>
+    <a:masterClrMapping/>
+  </p:clrMapOvr>
+</p:notes>
+</file>
+
+<file path=ppt/notesSlides/notesSlide18.xml><?xml version="1.0" encoding="utf-8"?>
+<p:notes xmlns:a="http://schemas.openxmlformats.org/drawingml/2006/main" xmlns:p="http://schemas.openxmlformats.org/presentationml/2006/main" xmlns:r="http://schemas.openxmlformats.org/officeDocument/2006/relationships">
+  <p:cSld>
+    <p:spTree>
+      <p:nvGrpSpPr>
+        <p:cNvPr id="1" name=""/>
+        <p:cNvGrpSpPr/>
+        <p:nvPr/>
+      </p:nvGrpSpPr>
+      <p:grpSpPr>
+        <a:xfrm>
+          <a:off x="0" y="0"/>
+          <a:ext cx="0" cy="0"/>
+          <a:chOff x="0" y="0"/>
+          <a:chExt cx="0" cy="0"/>
+        </a:xfrm>
+      </p:grpSpPr>
+      <p:sp>
+        <p:nvSpPr>
+          <p:cNvPr id="2" name="Slide Image Placeholder 1"/>
+          <p:cNvSpPr>
+            <a:spLocks noGrp="1"/>
+          </p:cNvSpPr>
+          <p:nvPr>
+            <p:ph type="sldImg" idx="2"/>
+          </p:nvPr>
+        </p:nvSpPr>
+        <p:spPr/>
+      </p:sp>
+      <p:sp>
+        <p:nvSpPr>
+          <p:cNvPr id="3" name="Notes Placeholder 2"/>
+          <p:cNvSpPr>
+            <a:spLocks noGrp="1"/>
+          </p:cNvSpPr>
+          <p:nvPr>
+            <p:ph type="body" idx="3" sz="quarter"/>
+          </p:nvPr>
+        </p:nvSpPr>
+        <p:spPr/>
+        <p:txBody>
+          <a:bodyPr/>
+          <a:lstStyle/>
+          <a:p>
+            <a:r>
+              <a:t>PRESENTER 5 — Kumar Swamy C.</a:t>
+            </a:r>
+          </a:p>
+          <a:p>
+            <a:r>
               <a:t>Thank the panel and open for questions. The whole team fields Q&amp;A — route each question to whoever owns that section.</a:t>
             </a:r>
           </a:p>
@@ -1198,7 +1274,7 @@
           </a:p>
           <a:p>
             <a:r>
-              <a:t>Motivation: LOB has microstructure signal; prior work is developed-markets/FI-2010 only; Indian index futures unstudied; no clean dataset existed.</a:t>
+              <a:t>Background &amp; overview: what a LOB is, the deep-LOB progression (DeepLOB-&gt;TLOB-&gt;Mamba), that it's all developed-markets, and our project abstract in one breath. Give the roadmap, then: 'Now the motivation in detail.'</a:t>
             </a:r>
           </a:p>
         </p:txBody>
@@ -1273,7 +1349,7 @@
           </a:p>
           <a:p>
             <a:r>
-              <a:t>State the objectives and the two research questions (efficient SSM? do features help?). Keep crisp.</a:t>
+              <a:t>Motivation: LOB has microstructure signal; prior work is developed-markets/FI-2010 only; Indian index futures unstudied; no clean dataset existed.</a:t>
             </a:r>
           </a:p>
         </p:txBody>
@@ -1348,7 +1424,7 @@
           </a:p>
           <a:p>
             <a:r>
-              <a:t>Related work in 4 names: FI-2010, DeepLOB, TLOB, Mamba/LOBCAST. Then: 'I'll hand over to Joseph for how we built our dataset.'</a:t>
+              <a:t>State the objectives and the two research questions (efficient SSM? do features help?). Keep crisp.</a:t>
             </a:r>
           </a:p>
         </p:txBody>
@@ -1418,12 +1494,12 @@
           <a:lstStyle/>
           <a:p>
             <a:r>
-              <a:t>PRESENTER 2 — Joseph Raj (Data Engineering &amp; Dataset). YOUR STRONGEST SLIDE.</a:t>
-            </a:r>
-          </a:p>
-          <a:p>
-            <a:r>
-              <a:t>Reverse-engineered Dhan binary feed (1992B/664B), EC2-&gt;Parquet-&gt;S3 pipeline, front-month stitch. ~1.1M events. This is the core contribution.</a:t>
+              <a:t>PRESENTER 1 — Sumanth G M.</a:t>
+            </a:r>
+          </a:p>
+          <a:p>
+            <a:r>
+              <a:t>Related work in 4 names: FI-2010, DeepLOB, TLOB, Mamba/LOBCAST. Then: 'I'll hand over to Joseph for how we built our dataset.'</a:t>
             </a:r>
           </a:p>
         </p:txBody>
@@ -1493,12 +1569,12 @@
           <a:lstStyle/>
           <a:p>
             <a:r>
-              <a:t>PRESENTER 2 — Joseph Raj.</a:t>
-            </a:r>
-          </a:p>
-          <a:p>
-            <a:r>
-              <a:t>Datasets: FI-2010 spec + engineered NSE spec; first 10 levels = 40 features = FI-2010 layout -&gt; models transfer unchanged. Be upfront: ~0.4s snapshot cadence, not tick-level.</a:t>
+              <a:t>PRESENTER 2 — Joseph Raj (Data Engineering &amp; Dataset). YOUR STRONGEST SLIDE.</a:t>
+            </a:r>
+          </a:p>
+          <a:p>
+            <a:r>
+              <a:t>Reverse-engineered Dhan binary feed (1992B/664B), EC2-&gt;Parquet-&gt;S3 pipeline, front-month stitch. ~1.1M events. This is the core contribution.</a:t>
             </a:r>
           </a:p>
         </p:txBody>
@@ -1573,7 +1649,7 @@
           </a:p>
           <a:p>
             <a:r>
-              <a:t>EDA: Stationary class shrinks 19%-&gt;4% with horizon; spread ~3.3 bps; regular ~2.5Hz cadence.</a:t>
+              <a:t>Datasets: FI-2010 spec + engineered NSE spec; first 10 levels = 40 features = FI-2010 layout -&gt; models transfer unchanged. Be upfront: ~0.4s snapshot cadence, not tick-level.</a:t>
             </a:r>
           </a:p>
         </p:txBody>
@@ -1648,7 +1724,7 @@
           </a:p>
           <a:p>
             <a:r>
-              <a:t>Preprocessing pipeline + labelling (alpha=1e-5) + engineered microstructure features. Hand to Abhishek for the models.</a:t>
+              <a:t>EDA: Stationary class shrinks 19%-&gt;4% with horizon; spread ~3.3 bps; regular ~2.5Hz cadence.</a:t>
             </a:r>
           </a:p>
         </p:txBody>
@@ -1718,12 +1794,12 @@
           <a:lstStyle/>
           <a:p>
             <a:r>
-              <a:t>PRESENTER 3 — Abhishek Kumar (Models &amp; Reproduction).</a:t>
-            </a:r>
-          </a:p>
-          <a:p>
-            <a:r>
-              <a:t>Baselines (DeepLOB/MLPLOB/TLOB) + proposed MambaLOB (selective SSM, O(L)) + ConvMambaLOB. One contract for all.</a:t>
+              <a:t>PRESENTER 2 — Joseph Raj.</a:t>
+            </a:r>
+          </a:p>
+          <a:p>
+            <a:r>
+              <a:t>Preprocessing pipeline + labelling (alpha=1e-5) + engineered microstructure features. Hand to Abhishek for the models.</a:t>
             </a:r>
           </a:p>
         </p:txBody>
@@ -4963,45 +5039,21 @@
                   <a:srgbClr val="1F4E79"/>
                 </a:solidFill>
               </a:rPr>
-              <a:t>Results — FI-2010 Reproduction</a:t>
-            </a:r>
-          </a:p>
-        </p:txBody>
-      </p:sp>
-      <p:pic>
-        <p:nvPicPr>
-          <p:cNvPr id="4" name="Picture 3" descr="fi2010_fig_macrof1_by_horizon.png"/>
-          <p:cNvPicPr>
-            <a:picLocks noChangeAspect="1"/>
-          </p:cNvPicPr>
-          <p:nvPr/>
-        </p:nvPicPr>
-        <p:blipFill>
-          <a:blip r:embed="rId2"/>
-          <a:stretch>
-            <a:fillRect/>
-          </a:stretch>
-        </p:blipFill>
-        <p:spPr>
-          <a:xfrm>
-            <a:off x="457200" y="1463040"/>
-            <a:ext cx="6583680" cy="5172347"/>
-          </a:xfrm>
-          <a:prstGeom prst="rect">
-            <a:avLst/>
-          </a:prstGeom>
-        </p:spPr>
-      </p:pic>
-      <p:sp>
-        <p:nvSpPr>
-          <p:cNvPr id="5" name="TextBox 4"/>
+              <a:t>Models</a:t>
+            </a:r>
+          </a:p>
+        </p:txBody>
+      </p:sp>
+      <p:sp>
+        <p:nvSpPr>
+          <p:cNvPr id="4" name="TextBox 3"/>
           <p:cNvSpPr txBox="1"/>
           <p:nvPr/>
         </p:nvSpPr>
         <p:spPr>
           <a:xfrm>
-            <a:off x="7315200" y="1463040"/>
-            <a:ext cx="4389120" cy="4572000"/>
+            <a:off x="548640" y="1371600"/>
+            <a:ext cx="11094415" cy="5120640"/>
           </a:xfrm>
           <a:prstGeom prst="rect">
             <a:avLst/>
@@ -5016,61 +5068,76 @@
           <a:p>
             <a:pPr>
               <a:spcAft>
-                <a:spcPts val="800"/>
+                <a:spcPts val="600"/>
               </a:spcAft>
             </a:pPr>
             <a:r>
-              <a:rPr sz="1700">
+              <a:rPr sz="2000">
                 <a:solidFill>
                   <a:srgbClr val="222222"/>
                 </a:solidFill>
               </a:rPr>
-              <a:t>• DeepLOB weighted-F1 ≈ 82.5% — matches paper (~83.4%).</a:t>
+              <a:t>• Baselines (reproduced): DeepLOB (CNN+Inception+LSTM), MLPLOB (MLP+BiN), TLOB (dual-attention transformer).</a:t>
             </a:r>
           </a:p>
           <a:p>
             <a:pPr>
               <a:spcAft>
-                <a:spcPts val="800"/>
+                <a:spcPts val="600"/>
               </a:spcAft>
             </a:pPr>
             <a:r>
-              <a:rPr sz="1700">
+              <a:rPr sz="2000">
                 <a:solidFill>
                   <a:srgbClr val="222222"/>
                 </a:solidFill>
               </a:rPr>
-              <a:t>• TLOB reaches the SOTA range (up to ~92.5%).</a:t>
+              <a:t>• MambaLOB (proposed): Linear → n selective state-space (Mamba) blocks → Bilinear Norm → FC(3).</a:t>
+            </a:r>
+          </a:p>
+          <a:p>
+            <a:pPr lvl="1">
+              <a:spcAft>
+                <a:spcPts val="600"/>
+              </a:spcAft>
+            </a:pPr>
+            <a:r>
+              <a:rPr sz="1800">
+                <a:solidFill>
+                  <a:srgbClr val="666666"/>
+                </a:solidFill>
+              </a:rPr>
+              <a:t>– Input-dependent linear recurrence → O(L) time &amp; memory, params independent of sequence length.</a:t>
             </a:r>
           </a:p>
           <a:p>
             <a:pPr>
               <a:spcAft>
-                <a:spcPts val="800"/>
+                <a:spcPts val="600"/>
               </a:spcAft>
             </a:pPr>
             <a:r>
-              <a:rPr sz="1700">
+              <a:rPr sz="2000">
                 <a:solidFill>
                   <a:srgbClr val="222222"/>
                 </a:solidFill>
               </a:rPr>
-              <a:t>• Ordering &amp; range match published + independent (LOBCAST) results.</a:t>
+              <a:t>• ConvMambaLOB: DeepLOB convolutional spatial front-end → Mamba temporal core (replaces the LSTM).</a:t>
             </a:r>
           </a:p>
           <a:p>
             <a:pPr>
               <a:spcAft>
-                <a:spcPts val="800"/>
+                <a:spcPts val="600"/>
               </a:spcAft>
             </a:pPr>
             <a:r>
-              <a:rPr sz="1700">
+              <a:rPr sz="2000">
                 <a:solidFill>
                   <a:srgbClr val="222222"/>
                 </a:solidFill>
               </a:rPr>
-              <a:t>• Validates the pipeline before transfer to NSE.</a:t>
+              <a:t>• All models share one (B, 100, 40) → 3-class contract for a fair comparison.</a:t>
             </a:r>
           </a:p>
         </p:txBody>
@@ -5164,14 +5231,14 @@
                   <a:srgbClr val="1F4E79"/>
                 </a:solidFill>
               </a:rPr>
-              <a:t>Results — NSE Transfer (Scheme A)</a:t>
+              <a:t>Results — FI-2010 Reproduction</a:t>
             </a:r>
           </a:p>
         </p:txBody>
       </p:sp>
       <p:pic>
         <p:nvPicPr>
-          <p:cNvPr id="4" name="Picture 3" descr="nse_fig_nse_wf1_by_horizon.png"/>
+          <p:cNvPr id="4" name="Picture 3" descr="fi2010_fig_macrof1_by_horizon.png"/>
           <p:cNvPicPr>
             <a:picLocks noChangeAspect="1"/>
           </p:cNvPicPr>
@@ -5186,7 +5253,7 @@
         <p:spPr>
           <a:xfrm>
             <a:off x="457200" y="1463040"/>
-            <a:ext cx="6583680" cy="2233141"/>
+            <a:ext cx="6583680" cy="5172347"/>
           </a:xfrm>
           <a:prstGeom prst="rect">
             <a:avLst/>
@@ -5226,7 +5293,7 @@
                   <a:srgbClr val="222222"/>
                 </a:solidFill>
               </a:rPr>
-              <a:t>• All models beat naive baselines → learnable signal exists.</a:t>
+              <a:t>• DeepLOB weighted-F1 ≈ 82.5% — matches paper (~83.4%).</a:t>
             </a:r>
           </a:p>
           <a:p>
@@ -5241,7 +5308,7 @@
                   <a:srgbClr val="222222"/>
                 </a:solidFill>
               </a:rPr>
-              <a:t>• Absolute scores below FI-2010 (expected, per LOBCAST).</a:t>
+              <a:t>• TLOB reaches the SOTA range (up to ~92.5%).</a:t>
             </a:r>
           </a:p>
           <a:p>
@@ -5256,7 +5323,7 @@
                   <a:srgbClr val="222222"/>
                 </a:solidFill>
               </a:rPr>
-              <a:t>• TLOB leads throughout.</a:t>
+              <a:t>• Ordering &amp; range match published + independent (LOBCAST) results.</a:t>
             </a:r>
           </a:p>
           <a:p>
@@ -5271,7 +5338,7 @@
                   <a:srgbClr val="222222"/>
                 </a:solidFill>
               </a:rPr>
-              <a:t>• Key: MambaLOB (68k) beats DeepLOB (191k) on NIFTY — transfers better than on FI-2010.</a:t>
+              <a:t>• Validates the pipeline before transfer to NSE.</a:t>
             </a:r>
           </a:p>
         </p:txBody>
@@ -5365,14 +5432,14 @@
                   <a:srgbClr val="1F4E79"/>
                 </a:solidFill>
               </a:rPr>
-              <a:t>Tier A — Microstructure Feature Engineering</a:t>
+              <a:t>Results — NSE Transfer (Scheme A)</a:t>
             </a:r>
           </a:p>
         </p:txBody>
       </p:sp>
       <p:pic>
         <p:nvPicPr>
-          <p:cNvPr id="4" name="Picture 3" descr="feature_ablation_fig_feature_ablation.png"/>
+          <p:cNvPr id="4" name="Picture 3" descr="nse_fig_nse_wf1_by_horizon.png"/>
           <p:cNvPicPr>
             <a:picLocks noChangeAspect="1"/>
           </p:cNvPicPr>
@@ -5387,7 +5454,7 @@
         <p:spPr>
           <a:xfrm>
             <a:off x="457200" y="1463040"/>
-            <a:ext cx="6583680" cy="4881966"/>
+            <a:ext cx="6583680" cy="2233141"/>
           </a:xfrm>
           <a:prstGeom prst="rect">
             <a:avLst/>
@@ -5427,7 +5494,7 @@
                   <a:srgbClr val="222222"/>
                 </a:solidFill>
               </a:rPr>
-              <a:t>• Engineered 'micro' / 'all' feature sets beat raw LOB.</a:t>
+              <a:t>• All models beat naive baselines → learnable signal exists.</a:t>
             </a:r>
           </a:p>
           <a:p>
@@ -5442,7 +5509,7 @@
                   <a:srgbClr val="222222"/>
                 </a:solidFill>
               </a:rPr>
-              <a:t>• Gain grows with horizon (up to +0.068 wF1 at k=100).</a:t>
+              <a:t>• Absolute scores below FI-2010 (expected, per LOBCAST).</a:t>
             </a:r>
           </a:p>
           <a:p>
@@ -5457,7 +5524,7 @@
                   <a:srgbClr val="222222"/>
                 </a:solidFill>
               </a:rPr>
-              <a:t>• Statistically significant: +0.084 wF1, p = 0.001 (multi-seed).</a:t>
+              <a:t>• TLOB leads throughout.</a:t>
             </a:r>
           </a:p>
           <a:p>
@@ -5472,7 +5539,7 @@
                   <a:srgbClr val="222222"/>
                 </a:solidFill>
               </a:rPr>
-              <a:t>• Order counts help only combined; deep levels add nothing.</a:t>
+              <a:t>• Key: MambaLOB (68k) beats DeepLOB (191k) on NIFTY — transfers better than on FI-2010.</a:t>
             </a:r>
           </a:p>
         </p:txBody>
@@ -5566,14 +5633,14 @@
                   <a:srgbClr val="1F4E79"/>
                 </a:solidFill>
               </a:rPr>
-              <a:t>Tier B — Improved Architectures</a:t>
+              <a:t>Tier A — Microstructure Feature Engineering</a:t>
             </a:r>
           </a:p>
         </p:txBody>
       </p:sp>
       <p:pic>
         <p:nvPicPr>
-          <p:cNvPr id="4" name="Picture 3" descr="architecture_fig_architecture.png"/>
+          <p:cNvPr id="4" name="Picture 3" descr="feature_ablation_fig_feature_ablation.png"/>
           <p:cNvPicPr>
             <a:picLocks noChangeAspect="1"/>
           </p:cNvPicPr>
@@ -5588,7 +5655,7 @@
         <p:spPr>
           <a:xfrm>
             <a:off x="457200" y="1463040"/>
-            <a:ext cx="6583680" cy="4672495"/>
+            <a:ext cx="6583680" cy="4881966"/>
           </a:xfrm>
           <a:prstGeom prst="rect">
             <a:avLst/>
@@ -5628,7 +5695,7 @@
                   <a:srgbClr val="222222"/>
                 </a:solidFill>
               </a:rPr>
-              <a:t>• ConvMambaLOB = best of the proposed variants.</a:t>
+              <a:t>• Engineered 'micro' / 'all' feature sets beat raw LOB.</a:t>
             </a:r>
           </a:p>
           <a:p>
@@ -5643,7 +5710,7 @@
                   <a:srgbClr val="222222"/>
                 </a:solidFill>
               </a:rPr>
-              <a:t>• Recovers ~90% of TLOB's quality at 12.5× fewer parameters.</a:t>
+              <a:t>• Gain grows with horizon (up to +0.068 wF1 at k=100).</a:t>
             </a:r>
           </a:p>
           <a:p>
@@ -5658,7 +5725,7 @@
                   <a:srgbClr val="222222"/>
                 </a:solidFill>
               </a:rPr>
-              <a:t>• Bidirectionality / stacking give diminishing returns.</a:t>
+              <a:t>• Statistically significant: +0.084 wF1, p = 0.001 (multi-seed).</a:t>
             </a:r>
           </a:p>
           <a:p>
@@ -5673,7 +5740,7 @@
                   <a:srgbClr val="222222"/>
                 </a:solidFill>
               </a:rPr>
-              <a:t>• Honest: an efficiency trade-off, not an accuracy win.</a:t>
+              <a:t>• Order counts help only combined; deep levels add nothing.</a:t>
             </a:r>
           </a:p>
         </p:txBody>
@@ -5767,21 +5834,45 @@
                   <a:srgbClr val="1F4E79"/>
                 </a:solidFill>
               </a:rPr>
-              <a:t>Tier C — Statistical Rigour</a:t>
-            </a:r>
-          </a:p>
-        </p:txBody>
-      </p:sp>
-      <p:sp>
-        <p:nvSpPr>
-          <p:cNvPr id="4" name="TextBox 3"/>
+              <a:t>Tier B — Improved Architectures</a:t>
+            </a:r>
+          </a:p>
+        </p:txBody>
+      </p:sp>
+      <p:pic>
+        <p:nvPicPr>
+          <p:cNvPr id="4" name="Picture 3" descr="architecture_fig_architecture.png"/>
+          <p:cNvPicPr>
+            <a:picLocks noChangeAspect="1"/>
+          </p:cNvPicPr>
+          <p:nvPr/>
+        </p:nvPicPr>
+        <p:blipFill>
+          <a:blip r:embed="rId2"/>
+          <a:stretch>
+            <a:fillRect/>
+          </a:stretch>
+        </p:blipFill>
+        <p:spPr>
+          <a:xfrm>
+            <a:off x="457200" y="1463040"/>
+            <a:ext cx="6583680" cy="4672495"/>
+          </a:xfrm>
+          <a:prstGeom prst="rect">
+            <a:avLst/>
+          </a:prstGeom>
+        </p:spPr>
+      </p:pic>
+      <p:sp>
+        <p:nvSpPr>
+          <p:cNvPr id="5" name="TextBox 4"/>
           <p:cNvSpPr txBox="1"/>
           <p:nvPr/>
         </p:nvSpPr>
         <p:spPr>
           <a:xfrm>
-            <a:off x="548640" y="1371600"/>
-            <a:ext cx="11094415" cy="5120640"/>
+            <a:off x="7315200" y="1463040"/>
+            <a:ext cx="4389120" cy="4572000"/>
           </a:xfrm>
           <a:prstGeom prst="rect">
             <a:avLst/>
@@ -5796,91 +5887,61 @@
           <a:p>
             <a:pPr>
               <a:spcAft>
-                <a:spcPts val="600"/>
+                <a:spcPts val="800"/>
               </a:spcAft>
             </a:pPr>
             <a:r>
-              <a:rPr sz="2000">
+              <a:rPr sz="1700">
                 <a:solidFill>
                   <a:srgbClr val="222222"/>
                 </a:solidFill>
               </a:rPr>
-              <a:t>• 3-seed study with paired across-seed + per-sample significance tests.</a:t>
+              <a:t>• ConvMambaLOB = best of the proposed variants.</a:t>
             </a:r>
           </a:p>
           <a:p>
             <a:pPr>
               <a:spcAft>
-                <a:spcPts val="600"/>
+                <a:spcPts val="800"/>
               </a:spcAft>
             </a:pPr>
             <a:r>
-              <a:rPr sz="2000">
+              <a:rPr sz="1700">
                 <a:solidFill>
                   <a:srgbClr val="222222"/>
                 </a:solidFill>
               </a:rPr>
-              <a:t>• Microstructure features: significant (p = 0.001). TLOB's accuracy lead: significant (p &lt; 0.001).</a:t>
-            </a:r>
-          </a:p>
-          <a:p>
-            <a:pPr lvl="1">
+              <a:t>• Recovers ~90% of TLOB's quality at 12.5× fewer parameters.</a:t>
+            </a:r>
+          </a:p>
+          <a:p>
+            <a:pPr>
               <a:spcAft>
-                <a:spcPts val="600"/>
+                <a:spcPts val="800"/>
               </a:spcAft>
             </a:pPr>
             <a:r>
-              <a:rPr sz="1800">
-                <a:solidFill>
-                  <a:srgbClr val="666666"/>
-                </a:solidFill>
-              </a:rPr>
-              <a:t>– ConvMambaLOB gain over base: not robust across seeds (p = 0.25).</a:t>
+              <a:rPr sz="1700">
+                <a:solidFill>
+                  <a:srgbClr val="222222"/>
+                </a:solidFill>
+              </a:rPr>
+              <a:t>• Bidirectionality / stacking give diminishing returns.</a:t>
             </a:r>
           </a:p>
           <a:p>
             <a:pPr>
               <a:spcAft>
-                <a:spcPts val="600"/>
+                <a:spcPts val="800"/>
               </a:spcAft>
             </a:pPr>
             <a:r>
-              <a:rPr sz="2000">
+              <a:rPr sz="1700">
                 <a:solidFill>
                   <a:srgbClr val="222222"/>
                 </a:solidFill>
               </a:rPr>
-              <a:t>• Hyperparameter optimisation (Optuna): tuned base MambaLOB (1 layer, d=32) matches the hybrid.</a:t>
-            </a:r>
-          </a:p>
-          <a:p>
-            <a:pPr>
-              <a:spcAft>
-                <a:spcPts val="600"/>
-              </a:spcAft>
-            </a:pPr>
-            <a:r>
-              <a:rPr sz="2000">
-                <a:solidFill>
-                  <a:srgbClr val="222222"/>
-                </a:solidFill>
-              </a:rPr>
-              <a:t>• Probability calibration: already well-calibrated (ECE 0.041, T = 1.00).</a:t>
-            </a:r>
-          </a:p>
-          <a:p>
-            <a:pPr>
-              <a:spcAft>
-                <a:spcPts val="600"/>
-              </a:spcAft>
-            </a:pPr>
-            <a:r>
-              <a:rPr sz="2000">
-                <a:solidFill>
-                  <a:srgbClr val="222222"/>
-                </a:solidFill>
-              </a:rPr>
-              <a:t>• Class imbalance: weighted cross-entropy a sound default; focal marginal at long horizons.</a:t>
+              <a:t>• Honest: an efficiency trade-off, not an accuracy win.</a:t>
             </a:r>
           </a:p>
         </p:txBody>
@@ -5974,45 +6035,21 @@
                   <a:srgbClr val="1F4E79"/>
                 </a:solidFill>
               </a:rPr>
-              <a:t>Efficiency — O(L) vs O(L²) Scaling</a:t>
-            </a:r>
-          </a:p>
-        </p:txBody>
-      </p:sp>
-      <p:pic>
-        <p:nvPicPr>
-          <p:cNvPr id="4" name="Picture 3" descr="mamba_fig_scaling_tlob_vs_mamba.png"/>
-          <p:cNvPicPr>
-            <a:picLocks noChangeAspect="1"/>
-          </p:cNvPicPr>
-          <p:nvPr/>
-        </p:nvPicPr>
-        <p:blipFill>
-          <a:blip r:embed="rId2"/>
-          <a:stretch>
-            <a:fillRect/>
-          </a:stretch>
-        </p:blipFill>
-        <p:spPr>
-          <a:xfrm>
-            <a:off x="457200" y="1463040"/>
-            <a:ext cx="6583680" cy="2340954"/>
-          </a:xfrm>
-          <a:prstGeom prst="rect">
-            <a:avLst/>
-          </a:prstGeom>
-        </p:spPr>
-      </p:pic>
-      <p:sp>
-        <p:nvSpPr>
-          <p:cNvPr id="5" name="TextBox 4"/>
+              <a:t>Tier C — Statistical Rigour</a:t>
+            </a:r>
+          </a:p>
+        </p:txBody>
+      </p:sp>
+      <p:sp>
+        <p:nvSpPr>
+          <p:cNvPr id="4" name="TextBox 3"/>
           <p:cNvSpPr txBox="1"/>
           <p:nvPr/>
         </p:nvSpPr>
         <p:spPr>
           <a:xfrm>
-            <a:off x="7315200" y="1463040"/>
-            <a:ext cx="4389120" cy="4572000"/>
+            <a:off x="548640" y="1371600"/>
+            <a:ext cx="11094415" cy="5120640"/>
           </a:xfrm>
           <a:prstGeom prst="rect">
             <a:avLst/>
@@ -6027,61 +6064,91 @@
           <a:p>
             <a:pPr>
               <a:spcAft>
-                <a:spcPts val="800"/>
+                <a:spcPts val="600"/>
               </a:spcAft>
             </a:pPr>
             <a:r>
-              <a:rPr sz="1700">
+              <a:rPr sz="2000">
                 <a:solidFill>
                   <a:srgbClr val="222222"/>
                 </a:solidFill>
               </a:rPr>
-              <a:t>• MambaLOB: parameters constant in L; memory/latency grow linearly.</a:t>
+              <a:t>• 3-seed study with paired across-seed + per-sample significance tests.</a:t>
             </a:r>
           </a:p>
           <a:p>
             <a:pPr>
               <a:spcAft>
-                <a:spcPts val="800"/>
+                <a:spcPts val="600"/>
               </a:spcAft>
             </a:pPr>
             <a:r>
-              <a:rPr sz="1700">
+              <a:rPr sz="2000">
                 <a:solidFill>
                   <a:srgbClr val="222222"/>
                 </a:solidFill>
               </a:rPr>
-              <a:t>• TLOB attention grows quadratically.</a:t>
+              <a:t>• Microstructure features: significant (p = 0.001). TLOB's accuracy lead: significant (p &lt; 0.001).</a:t>
+            </a:r>
+          </a:p>
+          <a:p>
+            <a:pPr lvl="1">
+              <a:spcAft>
+                <a:spcPts val="600"/>
+              </a:spcAft>
+            </a:pPr>
+            <a:r>
+              <a:rPr sz="1800">
+                <a:solidFill>
+                  <a:srgbClr val="666666"/>
+                </a:solidFill>
+              </a:rPr>
+              <a:t>– ConvMambaLOB gain over base: not robust across seeds (p = 0.25).</a:t>
             </a:r>
           </a:p>
           <a:p>
             <a:pPr>
               <a:spcAft>
-                <a:spcPts val="800"/>
+                <a:spcPts val="600"/>
               </a:spcAft>
             </a:pPr>
             <a:r>
-              <a:rPr sz="1700">
+              <a:rPr sz="2000">
                 <a:solidFill>
                   <a:srgbClr val="222222"/>
                 </a:solidFill>
               </a:rPr>
-              <a:t>• At L = 800: MambaLOB ≈ 31× faster, ≈ 750× fewer parameters.</a:t>
+              <a:t>• Hyperparameter optimisation (Optuna): tuned base MambaLOB (1 layer, d=32) matches the hybrid.</a:t>
             </a:r>
           </a:p>
           <a:p>
             <a:pPr>
               <a:spcAft>
-                <a:spcPts val="800"/>
+                <a:spcPts val="600"/>
               </a:spcAft>
             </a:pPr>
             <a:r>
-              <a:rPr sz="1700">
+              <a:rPr sz="2000">
                 <a:solidFill>
                   <a:srgbClr val="222222"/>
                 </a:solidFill>
               </a:rPr>
-              <a:t>• Basis of the architecture's efficiency claim.</a:t>
+              <a:t>• Probability calibration: already well-calibrated (ECE 0.041, T = 1.00).</a:t>
+            </a:r>
+          </a:p>
+          <a:p>
+            <a:pPr>
+              <a:spcAft>
+                <a:spcPts val="600"/>
+              </a:spcAft>
+            </a:pPr>
+            <a:r>
+              <a:rPr sz="2000">
+                <a:solidFill>
+                  <a:srgbClr val="222222"/>
+                </a:solidFill>
+              </a:rPr>
+              <a:t>• Class imbalance: weighted cross-entropy a sound default; focal marginal at long horizons.</a:t>
             </a:r>
           </a:p>
         </p:txBody>
@@ -6175,21 +6242,45 @@
                   <a:srgbClr val="1F4E79"/>
                 </a:solidFill>
               </a:rPr>
-              <a:t>Conclusion &amp; Future Work</a:t>
-            </a:r>
-          </a:p>
-        </p:txBody>
-      </p:sp>
-      <p:sp>
-        <p:nvSpPr>
-          <p:cNvPr id="4" name="TextBox 3"/>
+              <a:t>Efficiency — O(L) vs O(L²) Scaling</a:t>
+            </a:r>
+          </a:p>
+        </p:txBody>
+      </p:sp>
+      <p:pic>
+        <p:nvPicPr>
+          <p:cNvPr id="4" name="Picture 3" descr="mamba_fig_scaling_tlob_vs_mamba.png"/>
+          <p:cNvPicPr>
+            <a:picLocks noChangeAspect="1"/>
+          </p:cNvPicPr>
+          <p:nvPr/>
+        </p:nvPicPr>
+        <p:blipFill>
+          <a:blip r:embed="rId2"/>
+          <a:stretch>
+            <a:fillRect/>
+          </a:stretch>
+        </p:blipFill>
+        <p:spPr>
+          <a:xfrm>
+            <a:off x="457200" y="1463040"/>
+            <a:ext cx="6583680" cy="2340954"/>
+          </a:xfrm>
+          <a:prstGeom prst="rect">
+            <a:avLst/>
+          </a:prstGeom>
+        </p:spPr>
+      </p:pic>
+      <p:sp>
+        <p:nvSpPr>
+          <p:cNvPr id="5" name="TextBox 4"/>
           <p:cNvSpPr txBox="1"/>
           <p:nvPr/>
         </p:nvSpPr>
         <p:spPr>
           <a:xfrm>
-            <a:off x="548640" y="1371600"/>
-            <a:ext cx="11094415" cy="5120640"/>
+            <a:off x="7315200" y="1463040"/>
+            <a:ext cx="4389120" cy="4572000"/>
           </a:xfrm>
           <a:prstGeom prst="rect">
             <a:avLst/>
@@ -6204,76 +6295,61 @@
           <a:p>
             <a:pPr>
               <a:spcAft>
-                <a:spcPts val="600"/>
+                <a:spcPts val="800"/>
               </a:spcAft>
             </a:pPr>
             <a:r>
-              <a:rPr sz="2000">
+              <a:rPr sz="1700">
                 <a:solidFill>
                   <a:srgbClr val="222222"/>
                 </a:solidFill>
               </a:rPr>
-              <a:t>• Built the first ML-ready NSE index-futures LOB dataset via full reverse-engineering + cloud pipeline.</a:t>
+              <a:t>• MambaLOB: parameters constant in L; memory/latency grow linearly.</a:t>
             </a:r>
           </a:p>
           <a:p>
             <a:pPr>
               <a:spcAft>
-                <a:spcPts val="600"/>
+                <a:spcPts val="800"/>
               </a:spcAft>
             </a:pPr>
             <a:r>
-              <a:rPr sz="2000">
+              <a:rPr sz="1700">
                 <a:solidFill>
                   <a:srgbClr val="222222"/>
                 </a:solidFill>
               </a:rPr>
-              <a:t>• Reproduced baselines; introduced MambaLOB &amp; ConvMambaLOB; evaluated with multi-seed rigour.</a:t>
+              <a:t>• TLOB attention grows quadratically.</a:t>
             </a:r>
           </a:p>
           <a:p>
             <a:pPr>
               <a:spcAft>
-                <a:spcPts val="600"/>
+                <a:spcPts val="800"/>
               </a:spcAft>
             </a:pPr>
             <a:r>
-              <a:rPr sz="2000">
+              <a:rPr sz="1700">
                 <a:solidFill>
                   <a:srgbClr val="222222"/>
                 </a:solidFill>
               </a:rPr>
-              <a:t>• Headline (honest): SSM models reach ~90% of transformer accuracy at 12–25× fewer parameters — efficiency, not an accuracy win.</a:t>
+              <a:t>• At L = 800: MambaLOB ≈ 31× faster, ≈ 750× fewer parameters.</a:t>
             </a:r>
           </a:p>
           <a:p>
             <a:pPr>
               <a:spcAft>
-                <a:spcPts val="600"/>
+                <a:spcPts val="800"/>
               </a:spcAft>
             </a:pPr>
             <a:r>
-              <a:rPr sz="2000">
+              <a:rPr sz="1700">
                 <a:solidFill>
                   <a:srgbClr val="222222"/>
                 </a:solidFill>
               </a:rPr>
-              <a:t>• Largest significant gain comes from microstructure feature engineering, not architecture.</a:t>
-            </a:r>
-          </a:p>
-          <a:p>
-            <a:pPr>
-              <a:spcAft>
-                <a:spcPts val="600"/>
-              </a:spcAft>
-            </a:pPr>
-            <a:r>
-              <a:rPr sz="2000">
-                <a:solidFill>
-                  <a:srgbClr val="222222"/>
-                </a:solidFill>
-              </a:rPr>
-              <a:t>• Future work: spread-relative labelling, cost-aware backtest, walk-forward across more months/instruments.</a:t>
+              <a:t>• Basis of the architecture's efficiency claim.</a:t>
             </a:r>
           </a:p>
         </p:txBody>
@@ -6304,6 +6380,198 @@
         </p:nvSpPr>
         <p:spPr>
           <a:xfrm>
+            <a:off x="0" y="0"/>
+            <a:ext cx="12191695" cy="109728"/>
+          </a:xfrm>
+          <a:prstGeom prst="rect">
+            <a:avLst/>
+          </a:prstGeom>
+          <a:solidFill>
+            <a:srgbClr val="1F4E79"/>
+          </a:solidFill>
+          <a:ln>
+            <a:noFill/>
+          </a:ln>
+        </p:spPr>
+        <p:style>
+          <a:lnRef idx="1">
+            <a:schemeClr val="accent1"/>
+          </a:lnRef>
+          <a:fillRef idx="3">
+            <a:schemeClr val="accent1"/>
+          </a:fillRef>
+          <a:effectRef idx="2">
+            <a:schemeClr val="accent1"/>
+          </a:effectRef>
+          <a:fontRef idx="minor">
+            <a:schemeClr val="lt1"/>
+          </a:fontRef>
+        </p:style>
+        <p:txBody>
+          <a:bodyPr rtlCol="0" anchor="ctr"/>
+          <a:lstStyle/>
+          <a:p>
+            <a:pPr algn="ctr"/>
+          </a:p>
+        </p:txBody>
+      </p:sp>
+      <p:sp>
+        <p:nvSpPr>
+          <p:cNvPr id="3" name="TextBox 2"/>
+          <p:cNvSpPr txBox="1"/>
+          <p:nvPr/>
+        </p:nvSpPr>
+        <p:spPr>
+          <a:xfrm>
+            <a:off x="457200" y="256032"/>
+            <a:ext cx="11277295" cy="822960"/>
+          </a:xfrm>
+          <a:prstGeom prst="rect">
+            <a:avLst/>
+          </a:prstGeom>
+          <a:noFill/>
+        </p:spPr>
+        <p:txBody>
+          <a:bodyPr wrap="square">
+            <a:spAutoFit/>
+          </a:bodyPr>
+          <a:lstStyle/>
+          <a:p>
+            <a:r>
+              <a:rPr sz="3000" b="1">
+                <a:solidFill>
+                  <a:srgbClr val="1F4E79"/>
+                </a:solidFill>
+              </a:rPr>
+              <a:t>Conclusion &amp; Future Work</a:t>
+            </a:r>
+          </a:p>
+        </p:txBody>
+      </p:sp>
+      <p:sp>
+        <p:nvSpPr>
+          <p:cNvPr id="4" name="TextBox 3"/>
+          <p:cNvSpPr txBox="1"/>
+          <p:nvPr/>
+        </p:nvSpPr>
+        <p:spPr>
+          <a:xfrm>
+            <a:off x="548640" y="1371600"/>
+            <a:ext cx="11094415" cy="5120640"/>
+          </a:xfrm>
+          <a:prstGeom prst="rect">
+            <a:avLst/>
+          </a:prstGeom>
+          <a:noFill/>
+        </p:spPr>
+        <p:txBody>
+          <a:bodyPr wrap="square">
+            <a:spAutoFit/>
+          </a:bodyPr>
+          <a:lstStyle/>
+          <a:p>
+            <a:pPr>
+              <a:spcAft>
+                <a:spcPts val="600"/>
+              </a:spcAft>
+            </a:pPr>
+            <a:r>
+              <a:rPr sz="2000">
+                <a:solidFill>
+                  <a:srgbClr val="222222"/>
+                </a:solidFill>
+              </a:rPr>
+              <a:t>• Built the first ML-ready NSE index-futures LOB dataset via full reverse-engineering + cloud pipeline.</a:t>
+            </a:r>
+          </a:p>
+          <a:p>
+            <a:pPr>
+              <a:spcAft>
+                <a:spcPts val="600"/>
+              </a:spcAft>
+            </a:pPr>
+            <a:r>
+              <a:rPr sz="2000">
+                <a:solidFill>
+                  <a:srgbClr val="222222"/>
+                </a:solidFill>
+              </a:rPr>
+              <a:t>• Reproduced baselines; introduced MambaLOB &amp; ConvMambaLOB; evaluated with multi-seed rigour.</a:t>
+            </a:r>
+          </a:p>
+          <a:p>
+            <a:pPr>
+              <a:spcAft>
+                <a:spcPts val="600"/>
+              </a:spcAft>
+            </a:pPr>
+            <a:r>
+              <a:rPr sz="2000">
+                <a:solidFill>
+                  <a:srgbClr val="222222"/>
+                </a:solidFill>
+              </a:rPr>
+              <a:t>• Headline (honest): SSM models reach ~90% of transformer accuracy at 12–25× fewer parameters — efficiency, not an accuracy win.</a:t>
+            </a:r>
+          </a:p>
+          <a:p>
+            <a:pPr>
+              <a:spcAft>
+                <a:spcPts val="600"/>
+              </a:spcAft>
+            </a:pPr>
+            <a:r>
+              <a:rPr sz="2000">
+                <a:solidFill>
+                  <a:srgbClr val="222222"/>
+                </a:solidFill>
+              </a:rPr>
+              <a:t>• Largest significant gain comes from microstructure feature engineering, not architecture.</a:t>
+            </a:r>
+          </a:p>
+          <a:p>
+            <a:pPr>
+              <a:spcAft>
+                <a:spcPts val="600"/>
+              </a:spcAft>
+            </a:pPr>
+            <a:r>
+              <a:rPr sz="2000">
+                <a:solidFill>
+                  <a:srgbClr val="222222"/>
+                </a:solidFill>
+              </a:rPr>
+              <a:t>• Future work: spread-relative labelling, cost-aware backtest, walk-forward across more months/instruments.</a:t>
+            </a:r>
+          </a:p>
+        </p:txBody>
+      </p:sp>
+    </p:spTree>
+  </p:cSld>
+  <p:clrMapOvr>
+    <a:masterClrMapping/>
+  </p:clrMapOvr>
+</p:sld>
+</file>
+
+<file path=ppt/slides/slide18.xml><?xml version="1.0" encoding="utf-8"?>
+<p:sld xmlns:a="http://schemas.openxmlformats.org/drawingml/2006/main" xmlns:p="http://schemas.openxmlformats.org/presentationml/2006/main" xmlns:r="http://schemas.openxmlformats.org/officeDocument/2006/relationships">
+  <p:cSld>
+    <p:spTree>
+      <p:nvGrpSpPr>
+        <p:cNvPr id="1" name=""/>
+        <p:cNvGrpSpPr/>
+        <p:nvPr/>
+      </p:nvGrpSpPr>
+      <p:grpSpPr/>
+      <p:sp>
+        <p:nvSpPr>
+          <p:cNvPr id="2" name="Rectangle 1"/>
+          <p:cNvSpPr/>
+          <p:nvPr/>
+        </p:nvSpPr>
+        <p:spPr>
+          <a:xfrm>
             <a:off x="0" y="3017520"/>
             <a:ext cx="12191695" cy="91440"/>
           </a:xfrm>
@@ -6496,7 +6764,7 @@
                   <a:srgbClr val="1F4E79"/>
                 </a:solidFill>
               </a:rPr>
-              <a:t>Problem &amp; Motivation</a:t>
+              <a:t>Background &amp; Project Overview</a:t>
             </a:r>
           </a:p>
         </p:txBody>
@@ -6509,8 +6777,41 @@
         </p:nvSpPr>
         <p:spPr>
           <a:xfrm>
-            <a:off x="548640" y="1371600"/>
-            <a:ext cx="11094415" cy="5120640"/>
+            <a:off x="548640" y="1143000"/>
+            <a:ext cx="11094415" cy="457200"/>
+          </a:xfrm>
+          <a:prstGeom prst="rect">
+            <a:avLst/>
+          </a:prstGeom>
+          <a:noFill/>
+        </p:spPr>
+        <p:txBody>
+          <a:bodyPr wrap="square">
+            <a:spAutoFit/>
+          </a:bodyPr>
+          <a:lstStyle/>
+          <a:p>
+            <a:r>
+              <a:rPr sz="1500" i="1">
+                <a:solidFill>
+                  <a:srgbClr val="666666"/>
+                </a:solidFill>
+              </a:rPr>
+              <a:t>High-level context and abstract — the detailed literature survey follows in 'Related Work'.</a:t>
+            </a:r>
+          </a:p>
+        </p:txBody>
+      </p:sp>
+      <p:sp>
+        <p:nvSpPr>
+          <p:cNvPr id="5" name="TextBox 4"/>
+          <p:cNvSpPr txBox="1"/>
+          <p:nvPr/>
+        </p:nvSpPr>
+        <p:spPr>
+          <a:xfrm>
+            <a:off x="548640" y="1691640"/>
+            <a:ext cx="11094415" cy="4800600"/>
           </a:xfrm>
           <a:prstGeom prst="rect">
             <a:avLst/>
@@ -6534,7 +6835,7 @@
                   <a:srgbClr val="222222"/>
                 </a:solidFill>
               </a:rPr>
-              <a:t>• Predict short-horizon mid-price direction from Limit Order Book (LOB) data — Down / Stationary / Up.</a:t>
+              <a:t>• A Limit Order Book (LOB) records every resting buy/sell order at each price level — a rich, high-frequency signal.</a:t>
             </a:r>
           </a:p>
           <a:p>
@@ -6549,7 +6850,22 @@
                   <a:srgbClr val="222222"/>
                 </a:solidFill>
               </a:rPr>
-              <a:t>• LOB carries a rich microstructural signal; deep models show small but real predictive power.</a:t>
+              <a:t>• Deep learning on LOBs has steadily advanced mid-price prediction: CNN+LSTM (DeepLOB) → transformers (TLOB) → linear-time state-space models (Mamba).</a:t>
+            </a:r>
+          </a:p>
+          <a:p>
+            <a:pPr lvl="1">
+              <a:spcAft>
+                <a:spcPts val="600"/>
+              </a:spcAft>
+            </a:pPr>
+            <a:r>
+              <a:rPr sz="1800">
+                <a:solidFill>
+                  <a:srgbClr val="666666"/>
+                </a:solidFill>
+              </a:rPr>
+              <a:t>– But this progress sits almost entirely on developed markets and the public FI-2010 benchmark.</a:t>
             </a:r>
           </a:p>
           <a:p>
@@ -6564,22 +6880,7 @@
                   <a:srgbClr val="222222"/>
                 </a:solidFill>
               </a:rPr>
-              <a:t>• But research is concentrated on developed markets (NASDAQ, Nordic) and the FI-2010 benchmark.</a:t>
-            </a:r>
-          </a:p>
-          <a:p>
-            <a:pPr lvl="1">
-              <a:spcAft>
-                <a:spcPts val="600"/>
-              </a:spcAft>
-            </a:pPr>
-            <a:r>
-              <a:rPr sz="1800">
-                <a:solidFill>
-                  <a:srgbClr val="666666"/>
-                </a:solidFill>
-              </a:rPr>
-              <a:t>– Indian index futures are highly liquid yet structurally distinct and almost entirely unstudied with modern LOB architectures.</a:t>
+              <a:t>• This project, in brief: we engineer the first ML-ready Indian index-futures LOB dataset, reproduce the standard baselines, introduce MambaLOB / ConvMambaLOB, and characterise the efficiency–accuracy trade-off honestly.</a:t>
             </a:r>
           </a:p>
           <a:p>
@@ -6594,7 +6895,7 @@
                   <a:srgbClr val="222222"/>
                 </a:solidFill>
               </a:rPr>
-              <a:t>• No clean, ML-ready Indian index-futures LOB dataset existed — a data-engineering gap.</a:t>
+              <a:t>• Roadmap: motivation → data engineering → models → results → efficiency → conclusions.</a:t>
             </a:r>
           </a:p>
         </p:txBody>
@@ -6688,7 +6989,7 @@
                   <a:srgbClr val="1F4E79"/>
                 </a:solidFill>
               </a:rPr>
-              <a:t>Objectives &amp; Research Questions</a:t>
+              <a:t>Problem &amp; Motivation</a:t>
             </a:r>
           </a:p>
         </p:txBody>
@@ -6726,7 +7027,7 @@
                   <a:srgbClr val="222222"/>
                 </a:solidFill>
               </a:rPr>
-              <a:t>• Engineer the first ML-ready NSE index-futures LOB dataset (NIFTY, BANKNIFTY).</a:t>
+              <a:t>• Predict short-horizon mid-price direction from Limit Order Book (LOB) data — Down / Stationary / Up.</a:t>
             </a:r>
           </a:p>
           <a:p>
@@ -6741,7 +7042,7 @@
                   <a:srgbClr val="222222"/>
                 </a:solidFill>
               </a:rPr>
-              <a:t>• Reproduce published baselines (DeepLOB, MLPLOB, TLOB) on FI-2010 and validate.</a:t>
+              <a:t>• LOB carries a rich microstructural signal; deep models show small but real predictive power.</a:t>
             </a:r>
           </a:p>
           <a:p>
@@ -6756,7 +7057,22 @@
                   <a:srgbClr val="222222"/>
                 </a:solidFill>
               </a:rPr>
-              <a:t>• Introduce MambaLOB — a selective state-space model with linear-time O(L) scaling.</a:t>
+              <a:t>• But research is concentrated on developed markets (NASDAQ, Nordic) and the FI-2010 benchmark.</a:t>
+            </a:r>
+          </a:p>
+          <a:p>
+            <a:pPr lvl="1">
+              <a:spcAft>
+                <a:spcPts val="600"/>
+              </a:spcAft>
+            </a:pPr>
+            <a:r>
+              <a:rPr sz="1800">
+                <a:solidFill>
+                  <a:srgbClr val="666666"/>
+                </a:solidFill>
+              </a:rPr>
+              <a:t>– Indian index futures are highly liquid yet structurally distinct and almost entirely unstudied with modern LOB architectures.</a:t>
             </a:r>
           </a:p>
           <a:p>
@@ -6771,37 +7087,7 @@
                   <a:srgbClr val="222222"/>
                 </a:solidFill>
               </a:rPr>
-              <a:t>• Quantify transfer from FI-2010 to NSE, honestly reporting degradation.</a:t>
-            </a:r>
-          </a:p>
-          <a:p>
-            <a:pPr lvl="1">
-              <a:spcAft>
-                <a:spcPts val="600"/>
-              </a:spcAft>
-            </a:pPr>
-            <a:r>
-              <a:rPr sz="1800">
-                <a:solidFill>
-                  <a:srgbClr val="666666"/>
-                </a:solidFill>
-              </a:rPr>
-              <a:t>– RQ: Is a linear-time SSM competitive with the transformer at lower compute?</a:t>
-            </a:r>
-          </a:p>
-          <a:p>
-            <a:pPr lvl="1">
-              <a:spcAft>
-                <a:spcPts val="600"/>
-              </a:spcAft>
-            </a:pPr>
-            <a:r>
-              <a:rPr sz="1800">
-                <a:solidFill>
-                  <a:srgbClr val="666666"/>
-                </a:solidFill>
-              </a:rPr>
-              <a:t>– RQ: Does microstructure feature engineering improve the Indian-market signal?</a:t>
+              <a:t>• No clean, ML-ready Indian index-futures LOB dataset existed — a data-engineering gap.</a:t>
             </a:r>
           </a:p>
         </p:txBody>
@@ -6895,7 +7181,7 @@
                   <a:srgbClr val="1F4E79"/>
                 </a:solidFill>
               </a:rPr>
-              <a:t>Related Work</a:t>
+              <a:t>Objectives &amp; Research Questions</a:t>
             </a:r>
           </a:p>
         </p:txBody>
@@ -6933,7 +7219,7 @@
                   <a:srgbClr val="222222"/>
                 </a:solidFill>
               </a:rPr>
-              <a:t>• FI-2010 (Ntakaris et al., 2018) — first public LOB benchmark + protocol.</a:t>
+              <a:t>• Engineer the first ML-ready NSE index-futures LOB dataset (NIFTY, BANKNIFTY).</a:t>
             </a:r>
           </a:p>
           <a:p>
@@ -6948,7 +7234,7 @@
                   <a:srgbClr val="222222"/>
                 </a:solidFill>
               </a:rPr>
-              <a:t>• DeepLOB (Zhang et al., 2019) — CNN + Inception + LSTM; the 40-feature template.</a:t>
+              <a:t>• Reproduce published baselines (DeepLOB, MLPLOB, TLOB) on FI-2010 and validate.</a:t>
             </a:r>
           </a:p>
           <a:p>
@@ -6963,7 +7249,7 @@
                   <a:srgbClr val="222222"/>
                 </a:solidFill>
               </a:rPr>
-              <a:t>• MLPLOB / TLOB (Berti &amp; Kasneci, 2025) — dual-attention transformer, current SOTA.</a:t>
+              <a:t>• Introduce MambaLOB — a selective state-space model with linear-time O(L) scaling.</a:t>
             </a:r>
           </a:p>
           <a:p>
@@ -6978,37 +7264,37 @@
                   <a:srgbClr val="222222"/>
                 </a:solidFill>
               </a:rPr>
-              <a:t>• S4 / Mamba (Gu et al.) — structured / selective state-space models, sub-quadratic.</a:t>
-            </a:r>
-          </a:p>
-          <a:p>
-            <a:pPr>
+              <a:t>• Quantify transfer from FI-2010 to NSE, honestly reporting degradation.</a:t>
+            </a:r>
+          </a:p>
+          <a:p>
+            <a:pPr lvl="1">
               <a:spcAft>
                 <a:spcPts val="600"/>
               </a:spcAft>
             </a:pPr>
             <a:r>
-              <a:rPr sz="2000">
-                <a:solidFill>
-                  <a:srgbClr val="222222"/>
-                </a:solidFill>
-              </a:rPr>
-              <a:t>• LOBCAST (Prata et al., 2024) — benchmark study: models overfit FI-2010, drop on new data.</a:t>
-            </a:r>
-          </a:p>
-          <a:p>
-            <a:pPr>
+              <a:rPr sz="1800">
+                <a:solidFill>
+                  <a:srgbClr val="666666"/>
+                </a:solidFill>
+              </a:rPr>
+              <a:t>– RQ: Is a linear-time SSM competitive with the transformer at lower compute?</a:t>
+            </a:r>
+          </a:p>
+          <a:p>
+            <a:pPr lvl="1">
               <a:spcAft>
                 <a:spcPts val="600"/>
               </a:spcAft>
             </a:pPr>
             <a:r>
-              <a:rPr sz="2000">
-                <a:solidFill>
-                  <a:srgbClr val="222222"/>
-                </a:solidFill>
-              </a:rPr>
-              <a:t>• Microstructure priors: order-flow imbalance (Cont), micro-price (Stoikov).</a:t>
+              <a:rPr sz="1800">
+                <a:solidFill>
+                  <a:srgbClr val="666666"/>
+                </a:solidFill>
+              </a:rPr>
+              <a:t>– RQ: Does microstructure feature engineering improve the Indian-market signal?</a:t>
             </a:r>
           </a:p>
         </p:txBody>
@@ -7102,7 +7388,7 @@
                   <a:srgbClr val="1F4E79"/>
                 </a:solidFill>
               </a:rPr>
-              <a:t>Data Engineering — Building the NSE Dataset</a:t>
+              <a:t>Related Work</a:t>
             </a:r>
           </a:p>
         </p:txBody>
@@ -7115,41 +7401,8 @@
         </p:nvSpPr>
         <p:spPr>
           <a:xfrm>
-            <a:off x="548640" y="1143000"/>
-            <a:ext cx="11094415" cy="457200"/>
-          </a:xfrm>
-          <a:prstGeom prst="rect">
-            <a:avLst/>
-          </a:prstGeom>
-          <a:noFill/>
-        </p:spPr>
-        <p:txBody>
-          <a:bodyPr wrap="square">
-            <a:spAutoFit/>
-          </a:bodyPr>
-          <a:lstStyle/>
-          <a:p>
-            <a:r>
-              <a:rPr sz="1500" i="1">
-                <a:solidFill>
-                  <a:srgbClr val="666666"/>
-                </a:solidFill>
-              </a:rPr>
-              <a:t>The most substantial part of the project: no dataset existed, so we built one end-to-end.</a:t>
-            </a:r>
-          </a:p>
-        </p:txBody>
-      </p:sp>
-      <p:sp>
-        <p:nvSpPr>
-          <p:cNvPr id="5" name="TextBox 4"/>
-          <p:cNvSpPr txBox="1"/>
-          <p:nvPr/>
-        </p:nvSpPr>
-        <p:spPr>
-          <a:xfrm>
-            <a:off x="548640" y="1691640"/>
-            <a:ext cx="11094415" cy="4800600"/>
+            <a:off x="548640" y="1371600"/>
+            <a:ext cx="11094415" cy="5120640"/>
           </a:xfrm>
           <a:prstGeom prst="rect">
             <a:avLst/>
@@ -7173,22 +7426,7 @@
                   <a:srgbClr val="222222"/>
                 </a:solidFill>
               </a:rPr>
-              <a:t>• Reverse-engineered the undocumented Dhan 20-level binary depth feed (1992 B full / 664 B compact frames).</a:t>
-            </a:r>
-          </a:p>
-          <a:p>
-            <a:pPr lvl="1">
-              <a:spcAft>
-                <a:spcPts val="600"/>
-              </a:spcAft>
-            </a:pPr>
-            <a:r>
-              <a:rPr sz="1800">
-                <a:solidFill>
-                  <a:srgbClr val="666666"/>
-                </a:solidFill>
-              </a:rPr>
-              <a:t>– Fixed non-obvious decode issues: bid-price byte offset, denormalised empty levels, int64 overflow.</a:t>
+              <a:t>• FI-2010 (Ntakaris et al., 2018) — first public LOB benchmark + protocol.</a:t>
             </a:r>
           </a:p>
           <a:p>
@@ -7203,7 +7441,7 @@
                   <a:srgbClr val="222222"/>
                 </a:solidFill>
               </a:rPr>
-              <a:t>• Cloud collection: EC2 WebSocket collector → daily zstd Parquet → S3 (cron-scheduled, auto token refresh).</a:t>
+              <a:t>• DeepLOB (Zhang et al., 2019) — CNN + Inception + LSTM; the 40-feature template.</a:t>
             </a:r>
           </a:p>
           <a:p>
@@ -7218,7 +7456,7 @@
                   <a:srgbClr val="222222"/>
                 </a:solidFill>
               </a:rPr>
-              <a:t>• Front-month stitching across the May→June expiry roll; per-day segmentation.</a:t>
+              <a:t>• MLPLOB / TLOB (Berti &amp; Kasneci, 2025) — dual-attention transformer, current SOTA.</a:t>
             </a:r>
           </a:p>
           <a:p>
@@ -7233,7 +7471,37 @@
                   <a:srgbClr val="222222"/>
                 </a:solidFill>
               </a:rPr>
-              <a:t>• Result: 21 trading days, ~1.1 M events per instrument (exceeds FI-2010's ~400 k scale).</a:t>
+              <a:t>• S4 / Mamba (Gu et al.) — structured / selective state-space models, sub-quadratic.</a:t>
+            </a:r>
+          </a:p>
+          <a:p>
+            <a:pPr>
+              <a:spcAft>
+                <a:spcPts val="600"/>
+              </a:spcAft>
+            </a:pPr>
+            <a:r>
+              <a:rPr sz="2000">
+                <a:solidFill>
+                  <a:srgbClr val="222222"/>
+                </a:solidFill>
+              </a:rPr>
+              <a:t>• LOBCAST (Prata et al., 2024) — benchmark study: models overfit FI-2010, drop on new data.</a:t>
+            </a:r>
+          </a:p>
+          <a:p>
+            <a:pPr>
+              <a:spcAft>
+                <a:spcPts val="600"/>
+              </a:spcAft>
+            </a:pPr>
+            <a:r>
+              <a:rPr sz="2000">
+                <a:solidFill>
+                  <a:srgbClr val="222222"/>
+                </a:solidFill>
+              </a:rPr>
+              <a:t>• Microstructure priors: order-flow imbalance (Cont), micro-price (Stoikov).</a:t>
             </a:r>
           </a:p>
         </p:txBody>
@@ -7327,7 +7595,7 @@
                   <a:srgbClr val="1F4E79"/>
                 </a:solidFill>
               </a:rPr>
-              <a:t>Datasets</a:t>
+              <a:t>Data Engineering — Building the NSE Dataset</a:t>
             </a:r>
           </a:p>
         </p:txBody>
@@ -7340,8 +7608,41 @@
         </p:nvSpPr>
         <p:spPr>
           <a:xfrm>
-            <a:off x="548640" y="1371600"/>
-            <a:ext cx="11094415" cy="5120640"/>
+            <a:off x="548640" y="1143000"/>
+            <a:ext cx="11094415" cy="457200"/>
+          </a:xfrm>
+          <a:prstGeom prst="rect">
+            <a:avLst/>
+          </a:prstGeom>
+          <a:noFill/>
+        </p:spPr>
+        <p:txBody>
+          <a:bodyPr wrap="square">
+            <a:spAutoFit/>
+          </a:bodyPr>
+          <a:lstStyle/>
+          <a:p>
+            <a:r>
+              <a:rPr sz="1500" i="1">
+                <a:solidFill>
+                  <a:srgbClr val="666666"/>
+                </a:solidFill>
+              </a:rPr>
+              <a:t>The most substantial part of the project: no dataset existed, so we built one end-to-end.</a:t>
+            </a:r>
+          </a:p>
+        </p:txBody>
+      </p:sp>
+      <p:sp>
+        <p:nvSpPr>
+          <p:cNvPr id="5" name="TextBox 4"/>
+          <p:cNvSpPr txBox="1"/>
+          <p:nvPr/>
+        </p:nvSpPr>
+        <p:spPr>
+          <a:xfrm>
+            <a:off x="548640" y="1691640"/>
+            <a:ext cx="11094415" cy="4800600"/>
           </a:xfrm>
           <a:prstGeom prst="rect">
             <a:avLst/>
@@ -7365,7 +7666,22 @@
                   <a:srgbClr val="222222"/>
                 </a:solidFill>
               </a:rPr>
-              <a:t>• FI-2010 (benchmark): 5 Nasdaq Nordic stocks, 10 days, 10 levels, pre-normalised; horizons k = 10/20/50/100.</a:t>
+              <a:t>• Reverse-engineered the undocumented Dhan 20-level binary depth feed (1992 B full / 664 B compact frames).</a:t>
+            </a:r>
+          </a:p>
+          <a:p>
+            <a:pPr lvl="1">
+              <a:spcAft>
+                <a:spcPts val="600"/>
+              </a:spcAft>
+            </a:pPr>
+            <a:r>
+              <a:rPr sz="1800">
+                <a:solidFill>
+                  <a:srgbClr val="666666"/>
+                </a:solidFill>
+              </a:rPr>
+              <a:t>– Fixed non-obvious decode issues: bid-price byte offset, denormalised empty levels, int64 overflow.</a:t>
             </a:r>
           </a:p>
           <a:p>
@@ -7380,37 +7696,7 @@
                   <a:srgbClr val="222222"/>
                 </a:solidFill>
               </a:rPr>
-              <a:t>• NSE index futures (engineered): NIFTY &amp; BANKNIFTY 20-level depth via Dhan; 12 May – 12 June 2026.</a:t>
-            </a:r>
-          </a:p>
-          <a:p>
-            <a:pPr lvl="1">
-              <a:spcAft>
-                <a:spcPts val="600"/>
-              </a:spcAft>
-            </a:pPr>
-            <a:r>
-              <a:rPr sz="1800">
-                <a:solidFill>
-                  <a:srgbClr val="666666"/>
-                </a:solidFill>
-              </a:rPr>
-              <a:t>– First 10 of 20 levels → 40-feature vector identical in layout to FI-2010 → models transfer unchanged.</a:t>
-            </a:r>
-          </a:p>
-          <a:p>
-            <a:pPr lvl="1">
-              <a:spcAft>
-                <a:spcPts val="600"/>
-              </a:spcAft>
-            </a:pPr>
-            <a:r>
-              <a:rPr sz="1800">
-                <a:solidFill>
-                  <a:srgbClr val="666666"/>
-                </a:solidFill>
-              </a:rPr>
-              <a:t>– Stored cadence ≈ 0.4 s (~2.5 Hz) regular snapshots (honestly: not tick-by-tick).</a:t>
+              <a:t>• Cloud collection: EC2 WebSocket collector → daily zstd Parquet → S3 (cron-scheduled, auto token refresh).</a:t>
             </a:r>
           </a:p>
           <a:p>
@@ -7425,7 +7711,22 @@
                   <a:srgbClr val="222222"/>
                 </a:solidFill>
               </a:rPr>
-              <a:t>• Unique to Dhan: per-level order-count channel (absent from FI-2010 / Kite).</a:t>
+              <a:t>• Front-month stitching across the May→June expiry roll; per-day segmentation.</a:t>
+            </a:r>
+          </a:p>
+          <a:p>
+            <a:pPr>
+              <a:spcAft>
+                <a:spcPts val="600"/>
+              </a:spcAft>
+            </a:pPr>
+            <a:r>
+              <a:rPr sz="2000">
+                <a:solidFill>
+                  <a:srgbClr val="222222"/>
+                </a:solidFill>
+              </a:rPr>
+              <a:t>• Result: 21 trading days, ~1.1 M events per instrument (exceeds FI-2010's ~400 k scale).</a:t>
             </a:r>
           </a:p>
         </p:txBody>
@@ -7519,45 +7820,21 @@
                   <a:srgbClr val="1F4E79"/>
                 </a:solidFill>
               </a:rPr>
-              <a:t>Exploratory Data Analysis (NSE)</a:t>
-            </a:r>
-          </a:p>
-        </p:txBody>
-      </p:sp>
-      <p:pic>
-        <p:nvPicPr>
-          <p:cNvPr id="4" name="Picture 3" descr="eda_label_dist.png"/>
-          <p:cNvPicPr>
-            <a:picLocks noChangeAspect="1"/>
-          </p:cNvPicPr>
-          <p:nvPr/>
-        </p:nvPicPr>
-        <p:blipFill>
-          <a:blip r:embed="rId2"/>
-          <a:stretch>
-            <a:fillRect/>
-          </a:stretch>
-        </p:blipFill>
-        <p:spPr>
-          <a:xfrm>
-            <a:off x="457200" y="1463040"/>
-            <a:ext cx="6583680" cy="3709623"/>
-          </a:xfrm>
-          <a:prstGeom prst="rect">
-            <a:avLst/>
-          </a:prstGeom>
-        </p:spPr>
-      </p:pic>
-      <p:sp>
-        <p:nvSpPr>
-          <p:cNvPr id="5" name="TextBox 4"/>
+              <a:t>Datasets</a:t>
+            </a:r>
+          </a:p>
+        </p:txBody>
+      </p:sp>
+      <p:sp>
+        <p:nvSpPr>
+          <p:cNvPr id="4" name="TextBox 3"/>
           <p:cNvSpPr txBox="1"/>
           <p:nvPr/>
         </p:nvSpPr>
         <p:spPr>
           <a:xfrm>
-            <a:off x="7315200" y="1463040"/>
-            <a:ext cx="4389120" cy="4572000"/>
+            <a:off x="548640" y="1371600"/>
+            <a:ext cx="11094415" cy="5120640"/>
           </a:xfrm>
           <a:prstGeom prst="rect">
             <a:avLst/>
@@ -7572,61 +7849,76 @@
           <a:p>
             <a:pPr>
               <a:spcAft>
-                <a:spcPts val="800"/>
+                <a:spcPts val="600"/>
               </a:spcAft>
             </a:pPr>
             <a:r>
-              <a:rPr sz="1700">
+              <a:rPr sz="2000">
                 <a:solidFill>
                   <a:srgbClr val="222222"/>
                 </a:solidFill>
               </a:rPr>
-              <a:t>• Stationary class shrinks 19% → 4% as horizon k grows 10 → 100.</a:t>
+              <a:t>• FI-2010 (benchmark): 5 Nasdaq Nordic stocks, 10 days, 10 levels, pre-normalised; horizons k = 10/20/50/100.</a:t>
             </a:r>
           </a:p>
           <a:p>
             <a:pPr>
               <a:spcAft>
-                <a:spcPts val="800"/>
+                <a:spcPts val="600"/>
               </a:spcAft>
             </a:pPr>
             <a:r>
-              <a:rPr sz="1700">
+              <a:rPr sz="2000">
                 <a:solidFill>
                   <a:srgbClr val="222222"/>
                 </a:solidFill>
               </a:rPr>
-              <a:t>• Long-horizon task is effectively binary (Down/Up).</a:t>
+              <a:t>• NSE index futures (engineered): NIFTY &amp; BANKNIFTY 20-level depth via Dhan; 12 May – 12 June 2026.</a:t>
+            </a:r>
+          </a:p>
+          <a:p>
+            <a:pPr lvl="1">
+              <a:spcAft>
+                <a:spcPts val="600"/>
+              </a:spcAft>
+            </a:pPr>
+            <a:r>
+              <a:rPr sz="1800">
+                <a:solidFill>
+                  <a:srgbClr val="666666"/>
+                </a:solidFill>
+              </a:rPr>
+              <a:t>– First 10 of 20 levels → 40-feature vector identical in layout to FI-2010 → models transfer unchanged.</a:t>
+            </a:r>
+          </a:p>
+          <a:p>
+            <a:pPr lvl="1">
+              <a:spcAft>
+                <a:spcPts val="600"/>
+              </a:spcAft>
+            </a:pPr>
+            <a:r>
+              <a:rPr sz="1800">
+                <a:solidFill>
+                  <a:srgbClr val="666666"/>
+                </a:solidFill>
+              </a:rPr>
+              <a:t>– Stored cadence ≈ 0.4 s (~2.5 Hz) regular snapshots (honestly: not tick-by-tick).</a:t>
             </a:r>
           </a:p>
           <a:p>
             <a:pPr>
               <a:spcAft>
-                <a:spcPts val="800"/>
+                <a:spcPts val="600"/>
               </a:spcAft>
             </a:pPr>
             <a:r>
-              <a:rPr sz="1700">
+              <a:rPr sz="2000">
                 <a:solidFill>
                   <a:srgbClr val="222222"/>
                 </a:solidFill>
               </a:rPr>
-              <a:t>• Median relative spread ≈ 3.3 bps.</a:t>
-            </a:r>
-          </a:p>
-          <a:p>
-            <a:pPr>
-              <a:spcAft>
-                <a:spcPts val="800"/>
-              </a:spcAft>
-            </a:pPr>
-            <a:r>
-              <a:rPr sz="1700">
-                <a:solidFill>
-                  <a:srgbClr val="222222"/>
-                </a:solidFill>
-              </a:rPr>
-              <a:t>• Regular ~0.4 s update cadence (CV ≈ 0.34).</a:t>
+              <a:t>• Unique to Dhan: per-level order-count channel (absent from FI-2010 / Kite).</a:t>
             </a:r>
           </a:p>
         </p:txBody>
@@ -7720,21 +8012,45 @@
                   <a:srgbClr val="1F4E79"/>
                 </a:solidFill>
               </a:rPr>
-              <a:t>Preprocessing &amp; Labelling</a:t>
-            </a:r>
-          </a:p>
-        </p:txBody>
-      </p:sp>
-      <p:sp>
-        <p:nvSpPr>
-          <p:cNvPr id="4" name="TextBox 3"/>
+              <a:t>Exploratory Data Analysis (NSE)</a:t>
+            </a:r>
+          </a:p>
+        </p:txBody>
+      </p:sp>
+      <p:pic>
+        <p:nvPicPr>
+          <p:cNvPr id="4" name="Picture 3" descr="eda_label_dist.png"/>
+          <p:cNvPicPr>
+            <a:picLocks noChangeAspect="1"/>
+          </p:cNvPicPr>
+          <p:nvPr/>
+        </p:nvPicPr>
+        <p:blipFill>
+          <a:blip r:embed="rId2"/>
+          <a:stretch>
+            <a:fillRect/>
+          </a:stretch>
+        </p:blipFill>
+        <p:spPr>
+          <a:xfrm>
+            <a:off x="457200" y="1463040"/>
+            <a:ext cx="6583680" cy="3709623"/>
+          </a:xfrm>
+          <a:prstGeom prst="rect">
+            <a:avLst/>
+          </a:prstGeom>
+        </p:spPr>
+      </p:pic>
+      <p:sp>
+        <p:nvSpPr>
+          <p:cNvPr id="5" name="TextBox 4"/>
           <p:cNvSpPr txBox="1"/>
           <p:nvPr/>
         </p:nvSpPr>
         <p:spPr>
           <a:xfrm>
-            <a:off x="548640" y="1371600"/>
-            <a:ext cx="11094415" cy="5120640"/>
+            <a:off x="7315200" y="1463040"/>
+            <a:ext cx="4389120" cy="4572000"/>
           </a:xfrm>
           <a:prstGeom prst="rect">
             <a:avLst/>
@@ -7749,76 +8065,61 @@
           <a:p>
             <a:pPr>
               <a:spcAft>
-                <a:spcPts val="600"/>
+                <a:spcPts val="800"/>
               </a:spcAft>
             </a:pPr>
             <a:r>
-              <a:rPr sz="2000">
+              <a:rPr sz="1700">
                 <a:solidFill>
                   <a:srgbClr val="222222"/>
                 </a:solidFill>
               </a:rPr>
-              <a:t>• Reorder Dhan columns to interleaved FI-2010 layout [Pa, Va, Pb, Vb] × 10.</a:t>
+              <a:t>• Stationary class shrinks 19% → 4% as horizon k grows 10 → 100.</a:t>
             </a:r>
           </a:p>
           <a:p>
             <a:pPr>
               <a:spcAft>
-                <a:spcPts val="600"/>
+                <a:spcPts val="800"/>
               </a:spcAft>
             </a:pPr>
             <a:r>
-              <a:rPr sz="2000">
+              <a:rPr sz="1700">
                 <a:solidFill>
                   <a:srgbClr val="222222"/>
                 </a:solidFill>
               </a:rPr>
-              <a:t>• Clean crossed quotes and tick spikes; segment per trading day (no cross-day/contract windows).</a:t>
+              <a:t>• Long-horizon task is effectively binary (Down/Up).</a:t>
             </a:r>
           </a:p>
           <a:p>
             <a:pPr>
               <a:spcAft>
-                <a:spcPts val="600"/>
+                <a:spcPts val="800"/>
               </a:spcAft>
             </a:pPr>
             <a:r>
-              <a:rPr sz="2000">
+              <a:rPr sz="1700">
                 <a:solidFill>
                   <a:srgbClr val="222222"/>
                 </a:solidFill>
               </a:rPr>
-              <a:t>• Z-score using training statistics only; lazy 100-step sliding windows.</a:t>
+              <a:t>• Median relative spread ≈ 3.3 bps.</a:t>
             </a:r>
           </a:p>
           <a:p>
             <a:pPr>
               <a:spcAft>
-                <a:spcPts val="600"/>
+                <a:spcPts val="800"/>
               </a:spcAft>
             </a:pPr>
             <a:r>
-              <a:rPr sz="2000">
+              <a:rPr sz="1700">
                 <a:solidFill>
                   <a:srgbClr val="222222"/>
                 </a:solidFill>
               </a:rPr>
-              <a:t>• Labels (smoothed mid %-change): Up if r &gt; α, Down if r &lt; −α, else Stationary (fixed α = 1e-5).</a:t>
-            </a:r>
-          </a:p>
-          <a:p>
-            <a:pPr>
-              <a:spcAft>
-                <a:spcPts val="600"/>
-              </a:spcAft>
-            </a:pPr>
-            <a:r>
-              <a:rPr sz="2000">
-                <a:solidFill>
-                  <a:srgbClr val="222222"/>
-                </a:solidFill>
-              </a:rPr>
-              <a:t>• Microstructure features engineered: OFI, micro-price, depth imbalance, relative spread, order counts.</a:t>
+              <a:t>• Regular ~0.4 s update cadence (CV ≈ 0.34).</a:t>
             </a:r>
           </a:p>
         </p:txBody>
@@ -7912,7 +8213,7 @@
                   <a:srgbClr val="1F4E79"/>
                 </a:solidFill>
               </a:rPr>
-              <a:t>Models</a:t>
+              <a:t>Preprocessing &amp; Labelling</a:t>
             </a:r>
           </a:p>
         </p:txBody>
@@ -7950,7 +8251,7 @@
                   <a:srgbClr val="222222"/>
                 </a:solidFill>
               </a:rPr>
-              <a:t>• Baselines (reproduced): DeepLOB (CNN+Inception+LSTM), MLPLOB (MLP+BiN), TLOB (dual-attention transformer).</a:t>
+              <a:t>• Reorder Dhan columns to interleaved FI-2010 layout [Pa, Va, Pb, Vb] × 10.</a:t>
             </a:r>
           </a:p>
           <a:p>
@@ -7965,22 +8266,7 @@
                   <a:srgbClr val="222222"/>
                 </a:solidFill>
               </a:rPr>
-              <a:t>• MambaLOB (proposed): Linear → n selective state-space (Mamba) blocks → Bilinear Norm → FC(3).</a:t>
-            </a:r>
-          </a:p>
-          <a:p>
-            <a:pPr lvl="1">
-              <a:spcAft>
-                <a:spcPts val="600"/>
-              </a:spcAft>
-            </a:pPr>
-            <a:r>
-              <a:rPr sz="1800">
-                <a:solidFill>
-                  <a:srgbClr val="666666"/>
-                </a:solidFill>
-              </a:rPr>
-              <a:t>– Input-dependent linear recurrence → O(L) time &amp; memory, params independent of sequence length.</a:t>
+              <a:t>• Clean crossed quotes and tick spikes; segment per trading day (no cross-day/contract windows).</a:t>
             </a:r>
           </a:p>
           <a:p>
@@ -7995,7 +8281,7 @@
                   <a:srgbClr val="222222"/>
                 </a:solidFill>
               </a:rPr>
-              <a:t>• ConvMambaLOB: DeepLOB convolutional spatial front-end → Mamba temporal core (replaces the LSTM).</a:t>
+              <a:t>• Z-score using training statistics only; lazy 100-step sliding windows.</a:t>
             </a:r>
           </a:p>
           <a:p>
@@ -8010,7 +8296,22 @@
                   <a:srgbClr val="222222"/>
                 </a:solidFill>
               </a:rPr>
-              <a:t>• All models share one (B, 100, 40) → 3-class contract for a fair comparison.</a:t>
+              <a:t>• Labels (smoothed mid %-change): Up if r &gt; α, Down if r &lt; −α, else Stationary (fixed α = 1e-5).</a:t>
+            </a:r>
+          </a:p>
+          <a:p>
+            <a:pPr>
+              <a:spcAft>
+                <a:spcPts val="600"/>
+              </a:spcAft>
+            </a:pPr>
+            <a:r>
+              <a:rPr sz="2000">
+                <a:solidFill>
+                  <a:srgbClr val="222222"/>
+                </a:solidFill>
+              </a:rPr>
+              <a:t>• Microstructure features engineered: OFI, micro-price, depth imbalance, relative spread, order counts.</a:t>
             </a:r>
           </a:p>
         </p:txBody>

</xml_diff>

<commit_message>
docs/presentation: reassign presenters (Raghav, Kumar, Sumanth, Joseph, Abhishek)
Update per-slide speaker notes + prep-guide split table to the revised presenter
order across the 5 blocks. Noted that Joseph (DE author) fields deep
data-engineering Q&A even though Kumar presents that block.

Co-Authored-By: Claude Opus 4.8 (1M context) <noreply@anthropic.com>
</commit_message>
<xml_diff>
--- a/docs/presentation/Capstone_Final_Presentation.pptx
+++ b/docs/presentation/Capstone_Final_Presentation.pptx
@@ -519,7 +519,7 @@
           <a:lstStyle/>
           <a:p>
             <a:r>
-              <a:t>PRESENTER 1 — Sumanth G M (Intro &amp; Overview).</a:t>
+              <a:t>PRESENTER 1 — R Raghav Srivatsav (Intro &amp; Overview).</a:t>
             </a:r>
           </a:p>
           <a:p>
@@ -594,7 +594,7 @@
           <a:lstStyle/>
           <a:p>
             <a:r>
-              <a:t>PRESENTER 3 — Abhishek Kumar (Models &amp; Reproduction).</a:t>
+              <a:t>PRESENTER 3 — Sumanth G M (Models &amp; Reproduction).</a:t>
             </a:r>
           </a:p>
           <a:p>
@@ -669,7 +669,7 @@
           <a:lstStyle/>
           <a:p>
             <a:r>
-              <a:t>PRESENTER 3 — Abhishek Kumar.</a:t>
+              <a:t>PRESENTER 3 — Sumanth G M.</a:t>
             </a:r>
           </a:p>
           <a:p>
@@ -744,12 +744,12 @@
           <a:lstStyle/>
           <a:p>
             <a:r>
-              <a:t>PRESENTER 3 — Abhishek Kumar.</a:t>
-            </a:r>
-          </a:p>
-          <a:p>
-            <a:r>
-              <a:t>NSE transfer: all beat baselines (signal exists); below FI-2010 (expected); TLOB leads; MambaLOB beats DeepLOB on NIFTY at 1/27 params. Hand to Raghav for Phase-2.</a:t>
+              <a:t>PRESENTER 3 — Sumanth G M.</a:t>
+            </a:r>
+          </a:p>
+          <a:p>
+            <a:r>
+              <a:t>NSE transfer: all beat baselines (signal exists); below FI-2010 (expected); TLOB leads; MambaLOB beats DeepLOB on NIFTY at 1/27 params. Hand to Joseph for Phase-2.</a:t>
             </a:r>
           </a:p>
         </p:txBody>
@@ -819,7 +819,7 @@
           <a:lstStyle/>
           <a:p>
             <a:r>
-              <a:t>PRESENTER 4 — R Raghav Srivatsav (Phase-2 DS contributions).</a:t>
+              <a:t>PRESENTER 4 — Joseph Raj (Phase-2 DS contributions).</a:t>
             </a:r>
           </a:p>
           <a:p>
@@ -894,7 +894,7 @@
           <a:lstStyle/>
           <a:p>
             <a:r>
-              <a:t>PRESENTER 4 — R Raghav Srivatsav.</a:t>
+              <a:t>PRESENTER 4 — Joseph Raj.</a:t>
             </a:r>
           </a:p>
           <a:p>
@@ -969,12 +969,12 @@
           <a:lstStyle/>
           <a:p>
             <a:r>
-              <a:t>PRESENTER 4 — R Raghav Srivatsav.</a:t>
-            </a:r>
-          </a:p>
-          <a:p>
-            <a:r>
-              <a:t>Tier C rigour: multi-seed significance, calibration (ECE 0.041), HPO, class-imbalance. Features significant; ConvMamba gain not robust (we report it honestly). Hand to Kumar Swamy.</a:t>
+              <a:t>PRESENTER 4 — Joseph Raj.</a:t>
+            </a:r>
+          </a:p>
+          <a:p>
+            <a:r>
+              <a:t>Tier C rigour: multi-seed significance, calibration (ECE 0.041), HPO, class-imbalance. Features significant; ConvMamba gain not robust (we report it honestly). Hand to Abhishek.</a:t>
             </a:r>
           </a:p>
         </p:txBody>
@@ -1044,7 +1044,7 @@
           <a:lstStyle/>
           <a:p>
             <a:r>
-              <a:t>PRESENTER 5 — Kumar Swamy C (Efficiency, Conclusion &amp; Q&amp;A).</a:t>
+              <a:t>PRESENTER 5 — Abhishek Kumar (Efficiency, Conclusion &amp; Q&amp;A).</a:t>
             </a:r>
           </a:p>
           <a:p>
@@ -1119,7 +1119,7 @@
           <a:lstStyle/>
           <a:p>
             <a:r>
-              <a:t>PRESENTER 5 — Kumar Swamy C.</a:t>
+              <a:t>PRESENTER 5 — Abhishek Kumar.</a:t>
             </a:r>
           </a:p>
           <a:p>
@@ -1194,12 +1194,12 @@
           <a:lstStyle/>
           <a:p>
             <a:r>
-              <a:t>PRESENTER 5 — Kumar Swamy C.</a:t>
-            </a:r>
-          </a:p>
-          <a:p>
-            <a:r>
-              <a:t>Thank the panel and open for questions. The whole team fields Q&amp;A — route each question to whoever owns that section.</a:t>
+              <a:t>PRESENTER 5 — Abhishek Kumar.</a:t>
+            </a:r>
+          </a:p>
+          <a:p>
+            <a:r>
+              <a:t>Thank the panel and open for questions. The whole team fields Q&amp;A — route each question to whoever owns that section (deep data-engineering -&gt; Joseph).</a:t>
             </a:r>
           </a:p>
         </p:txBody>
@@ -1269,7 +1269,7 @@
           <a:lstStyle/>
           <a:p>
             <a:r>
-              <a:t>PRESENTER 1 — Sumanth G M.</a:t>
+              <a:t>PRESENTER 1 — R Raghav Srivatsav.</a:t>
             </a:r>
           </a:p>
           <a:p>
@@ -1344,7 +1344,7 @@
           <a:lstStyle/>
           <a:p>
             <a:r>
-              <a:t>PRESENTER 1 — Sumanth G M.</a:t>
+              <a:t>PRESENTER 1 — R Raghav Srivatsav.</a:t>
             </a:r>
           </a:p>
           <a:p>
@@ -1419,7 +1419,7 @@
           <a:lstStyle/>
           <a:p>
             <a:r>
-              <a:t>PRESENTER 1 — Sumanth G M.</a:t>
+              <a:t>PRESENTER 1 — R Raghav Srivatsav.</a:t>
             </a:r>
           </a:p>
           <a:p>
@@ -1494,12 +1494,12 @@
           <a:lstStyle/>
           <a:p>
             <a:r>
-              <a:t>PRESENTER 1 — Sumanth G M.</a:t>
-            </a:r>
-          </a:p>
-          <a:p>
-            <a:r>
-              <a:t>Related work in 4 names: FI-2010, DeepLOB, TLOB, Mamba/LOBCAST. Then: 'I'll hand over to Joseph for how we built our dataset.'</a:t>
+              <a:t>PRESENTER 1 — R Raghav Srivatsav.</a:t>
+            </a:r>
+          </a:p>
+          <a:p>
+            <a:r>
+              <a:t>Related work in 4 names: FI-2010, DeepLOB, TLOB, Mamba/LOBCAST. Then: 'I'll hand over to Kumar for how we built our dataset.'</a:t>
             </a:r>
           </a:p>
         </p:txBody>
@@ -1569,12 +1569,12 @@
           <a:lstStyle/>
           <a:p>
             <a:r>
-              <a:t>PRESENTER 2 — Joseph Raj (Data Engineering &amp; Dataset). YOUR STRONGEST SLIDE.</a:t>
-            </a:r>
-          </a:p>
-          <a:p>
-            <a:r>
-              <a:t>Reverse-engineered Dhan binary feed (1992B/664B), EC2-&gt;Parquet-&gt;S3 pipeline, front-month stitch. ~1.1M events. This is the core contribution.</a:t>
+              <a:t>PRESENTER 2 — Kumar Swamy C (Data Engineering &amp; Dataset). THE PROJECT'S STRONGEST SLIDE.</a:t>
+            </a:r>
+          </a:p>
+          <a:p>
+            <a:r>
+              <a:t>Reverse-engineered Dhan binary feed (1992B/664B), EC2-&gt;Parquet-&gt;S3 pipeline, front-month stitch. ~1.1M events. (Joseph built this — route deep DE questions to him in Q&amp;A.)</a:t>
             </a:r>
           </a:p>
         </p:txBody>
@@ -1644,7 +1644,7 @@
           <a:lstStyle/>
           <a:p>
             <a:r>
-              <a:t>PRESENTER 2 — Joseph Raj.</a:t>
+              <a:t>PRESENTER 2 — Kumar Swamy C.</a:t>
             </a:r>
           </a:p>
           <a:p>
@@ -1719,7 +1719,7 @@
           <a:lstStyle/>
           <a:p>
             <a:r>
-              <a:t>PRESENTER 2 — Joseph Raj.</a:t>
+              <a:t>PRESENTER 2 — Kumar Swamy C.</a:t>
             </a:r>
           </a:p>
           <a:p>
@@ -1794,12 +1794,12 @@
           <a:lstStyle/>
           <a:p>
             <a:r>
-              <a:t>PRESENTER 2 — Joseph Raj.</a:t>
-            </a:r>
-          </a:p>
-          <a:p>
-            <a:r>
-              <a:t>Preprocessing pipeline + labelling (alpha=1e-5) + engineered microstructure features. Hand to Abhishek for the models.</a:t>
+              <a:t>PRESENTER 2 — Kumar Swamy C.</a:t>
+            </a:r>
+          </a:p>
+          <a:p>
+            <a:r>
+              <a:t>Preprocessing pipeline + labelling (alpha=1e-5) + engineered microstructure features. Hand to Sumanth for the models.</a:t>
             </a:r>
           </a:p>
         </p:txBody>

</xml_diff>

<commit_message>
docs/presentation: move NSE Transfer (slide 12) to Joseph's block
Joseph now presents slides 12-15 (NSE Transfer + Tier A/B/C); Sumanth keeps
10-11 (Models + FI-2010 reproduction). NSE transfer opens Joseph's block and
bridges into the Phase-2 improvements. Speaker notes + prep table updated
(split now 5/4/2/4/3).

Co-Authored-By: Claude Opus 4.8 (1M context) <noreply@anthropic.com>
</commit_message>
<xml_diff>
--- a/docs/presentation/Capstone_Final_Presentation.pptx
+++ b/docs/presentation/Capstone_Final_Presentation.pptx
@@ -674,7 +674,7 @@
           </a:p>
           <a:p>
             <a:r>
-              <a:t>FI-2010 reproduction validates the pipeline: DeepLOB ~= paper, TLOB in SOTA range.</a:t>
+              <a:t>FI-2010 reproduction validates the pipeline: DeepLOB ~= paper, TLOB in SOTA range. Then hand to Joseph for the NSE transfer + Phase-2.</a:t>
             </a:r>
           </a:p>
         </p:txBody>
@@ -744,12 +744,12 @@
           <a:lstStyle/>
           <a:p>
             <a:r>
-              <a:t>PRESENTER 3 — Sumanth G M.</a:t>
-            </a:r>
-          </a:p>
-          <a:p>
-            <a:r>
-              <a:t>NSE transfer: all beat baselines (signal exists); below FI-2010 (expected); TLOB leads; MambaLOB beats DeepLOB on NIFTY at 1/27 params. Hand to Joseph for Phase-2.</a:t>
+              <a:t>PRESENTER 4 — Joseph Raj.</a:t>
+            </a:r>
+          </a:p>
+          <a:p>
+            <a:r>
+              <a:t>NSE transfer (your opener): all beat baselines (signal exists); below FI-2010 (expected, per LOBCAST); TLOB leads; MambaLOB beats DeepLOB on NIFTY at 1/27 params and transfers BETTER to NSE than on FI-2010. Bridge: 'these use raw features -- next, what microstructure features add.'</a:t>
             </a:r>
           </a:p>
         </p:txBody>

</xml_diff>